<commit_message>
Jobs-Folie ergänzt: Handwerker / Hausmeister gesucht
Neue Folie 19 im Team-Kapitel als Empfehlungsaufruf ans Team, nicht
als Stellenanzeige - Kollegenempfehlung ist bei dieser Rolle der
wirksamste Kanal.

- Offene Stelle und knappes Anforderungsprofil
- Aufruf "Kennt ihr jemanden?" mit konkreten Denkanstößen
- Einordnung, warum jetzt: Wachstum Kassel, Dortmund ab Oktober,
  mehr betreute Objekte
- Niedrigschwelliger Rückmeldeweg (Name und Nummer genügen)

Als sechster Punkt zusätzlich auf der Takeaway-Folie, damit der
Aufruf am Ende noch einmal hängen bleibt; Agenda entsprechend
angepasst.

Eckdaten (Vollzeit/Teilzeit, Startdatum, Einsatzort, mögliche
Empfehlungsprämie) sind bewusst offen und als Platzhalter-Hinweis
in den Sprechernotizen vermerkt.

Co-Authored-By: Claude Opus 5 <noreply@anthropic.com>
Claude-Session: https://claude.ai/code/session_01FbTPX12wq4Fo9HGjNDbeSj
</commit_message>
<xml_diff>
--- a/WERKE_Teammeeting_2026-08-07.pptx
+++ b/WERKE_Teammeeting_2026-08-07.pptx
@@ -25,9 +25,10 @@
     <p:sldId id="273" r:id="rId19"/>
     <p:sldId id="274" r:id="rId20"/>
     <p:sldId id="275" r:id="rId21"/>
+    <p:sldId id="276" r:id="rId22"/>
   </p:sldIdLst>
   <p:notesMasterIdLst>
-    <p:notesMasterId r:id="rId22"/>
+    <p:notesMasterId r:id="rId23"/>
   </p:notesMasterIdLst>
   <p:sldSz cx="12192000" cy="6858000"/>
   <p:notesSz cx="6858000" cy="12192000"/>
@@ -1418,10 +1419,10 @@
           <a:p>
             <a:r>
               <a:rPr lang="en-US" dirty="0"/>
-              <a:t>Lockerer Teil, entsprechend im Ton.
-Das After-Five-Grillen ist der Aufhaenger fuer gute Stimmung zum Schluss - ruhig etwas Vorfreude machen. Den genauen Termin nachreichen.
-JobRad, Volksbank und SCP sind reine Infos, nicht ausbreiten.
-PLATZHALTER: Bei den Opel-Papieren bitte pruefen, ob Melissa im Urlaub ist - gegebenenfalls die Vertretung nennen.</a:t>
+              <a:t>PLATZHALTER-HINWEIS: Bitte vor dem Meeting ergaenzen, was du konkret sagen moechtest - Vollzeit oder Teilzeit, ab wann, Einsatzort, und ob es eine Praemie fuer eine erfolgreiche Empfehlung gibt. Die Folie ist bewusst offen gehalten, weil ich die Eckdaten nicht kenne.
+Eine Praemie waere hier der wirksamste Hebel - wenn es eine gibt, unbedingt nennen.
+Wichtig beim Vortragen: nicht als Randnotiz abhandeln. Kurz Stille lassen, damit die Leute wirklich ueberlegen. Und am besten direkt fragen, ob jemand spontan einen Namen im Kopf hat.
+Wer etwas sagt: sofort notieren, nicht auf spaeter vertroesten.</a:t>
             </a:r>
             <a:endParaRPr lang="en-US" dirty="0"/>
           </a:p>
@@ -1598,9 +1599,10 @@
           <a:p>
             <a:r>
               <a:rPr lang="en-US" dirty="0"/>
-              <a:t>Die fuenf Punkte laut vorlesen - das sind die Saetze, die im Kopf bleiben sollen.
-Punkt 3 ist der mit dem Zeitdruck: bitte noch einmal betonen, dass das Foerderfenster am 10. November zufaellt.
-Dann Raum fuer Fragen. Was ich nicht beantworten kann, notiere ich und pflege es nach.</a:t>
+              <a:t>Lockerer Teil, entsprechend im Ton.
+Das After-Five-Grillen ist der Aufhaenger fuer gute Stimmung zum Schluss - ruhig etwas Vorfreude machen. Den genauen Termin nachreichen.
+JobRad, Volksbank und SCP sind reine Infos, nicht ausbreiten.
+PLATZHALTER: Bei den Opel-Papieren bitte pruefen, ob Melissa im Urlaub ist - gegebenenfalls die Vertretung nennen.</a:t>
             </a:r>
             <a:endParaRPr lang="en-US" dirty="0"/>
           </a:p>
@@ -1624,6 +1626,97 @@
             <a:fld id="{F7021451-1387-4CA6-816F-3879F97B5CBC}" type="slidenum">
               <a:rPr lang="en-US"/>
               <a:t>20</a:t>
+            </a:fld>
+            <a:endParaRPr lang="en-US"/>
+          </a:p>
+        </p:txBody>
+      </p:sp>
+    </p:spTree>
+    <p:extLst>
+      <p:ext uri="{BB962C8B-B14F-4D97-AF65-F5344CB8AC3E}">
+        <p14:creationId xmlns:p14="http://schemas.microsoft.com/office/powerpoint/2010/main" val="1024086991"/>
+      </p:ext>
+    </p:extLst>
+  </p:cSld>
+  <p:clrMapOvr>
+    <a:masterClrMapping/>
+  </p:clrMapOvr>
+</p:notes>
+</file>
+
+<file path=ppt/notesSlides/notesSlide21.xml><?xml version="1.0" encoding="utf-8"?>
+<p:notes xmlns:a="http://schemas.openxmlformats.org/drawingml/2006/main" xmlns:r="http://schemas.openxmlformats.org/officeDocument/2006/relationships" xmlns:p="http://schemas.openxmlformats.org/presentationml/2006/main">
+  <p:cSld>
+    <p:spTree>
+      <p:nvGrpSpPr>
+        <p:cNvPr id="1" name=""/>
+        <p:cNvGrpSpPr/>
+        <p:nvPr/>
+      </p:nvGrpSpPr>
+      <p:grpSpPr>
+        <a:xfrm>
+          <a:off x="0" y="0"/>
+          <a:ext cx="0" cy="0"/>
+          <a:chOff x="0" y="0"/>
+          <a:chExt cx="0" cy="0"/>
+        </a:xfrm>
+      </p:grpSpPr>
+      <p:sp>
+        <p:nvSpPr>
+          <p:cNvPr id="2" name="Slide Image Placeholder 1"/>
+          <p:cNvSpPr>
+            <a:spLocks noGrp="1" noRot="1" noChangeAspect="1"/>
+          </p:cNvSpPr>
+          <p:nvPr>
+            <p:ph type="sldImg"/>
+          </p:nvPr>
+        </p:nvSpPr>
+        <p:spPr/>
+      </p:sp>
+      <p:sp>
+        <p:nvSpPr>
+          <p:cNvPr id="3" name="Notes Placeholder 2"/>
+          <p:cNvSpPr>
+            <a:spLocks noGrp="1"/>
+          </p:cNvSpPr>
+          <p:nvPr>
+            <p:ph type="body" idx="1"/>
+          </p:nvPr>
+        </p:nvSpPr>
+        <p:spPr/>
+        <p:txBody>
+          <a:bodyPr/>
+          <a:lstStyle/>
+          <a:p>
+            <a:r>
+              <a:rPr lang="en-US" dirty="0"/>
+              <a:t>Die sechs Punkte laut vorlesen - das sind die Saetze, die im Kopf bleiben sollen.
+Punkt 3 ist der mit dem Zeitdruck: bitte noch einmal betonen, dass das Foerderfenster am 10. November zufaellt.
+Punkt 6 zum Schluss noch einmal ernst meinen - nicht nur vorlesen. Wer heute einen Namen nennt, spart uns Wochen.
+Dann Raum fuer Fragen. Was ich nicht beantworten kann, notiere ich und pflege es nach.</a:t>
+            </a:r>
+            <a:endParaRPr lang="en-US" dirty="0"/>
+          </a:p>
+        </p:txBody>
+      </p:sp>
+      <p:sp>
+        <p:nvSpPr>
+          <p:cNvPr id="4" name="Slide Number Placeholder 3"/>
+          <p:cNvSpPr>
+            <a:spLocks noGrp="1"/>
+          </p:cNvSpPr>
+          <p:nvPr>
+            <p:ph type="sldNum" sz="quarter" idx="10"/>
+          </p:nvPr>
+        </p:nvSpPr>
+        <p:spPr/>
+        <p:txBody>
+          <a:bodyPr/>
+          <a:lstStyle/>
+          <a:p>
+            <a:fld id="{F7021451-1387-4CA6-816F-3879F97B5CBC}" type="slidenum">
+              <a:rPr lang="en-US"/>
+              <a:t>21</a:t>
             </a:fld>
             <a:endParaRPr lang="en-US"/>
           </a:p>
@@ -9727,7 +9820,7 @@
                 <a:ea typeface="Calibri" pitchFamily="34" charset="-122"/>
                 <a:cs typeface="Calibri" pitchFamily="34" charset="-120"/>
               </a:rPr>
-              <a:t>KAPITEL 3 · TERMINE</a:t>
+              <a:t>KAPITEL 3 · JOBS</a:t>
             </a:r>
             <a:endParaRPr lang="en-US" sz="1100" dirty="0"/>
           </a:p>
@@ -9766,7 +9859,7 @@
                 <a:ea typeface="Trebuchet MS" pitchFamily="34" charset="-122"/>
                 <a:cs typeface="Trebuchet MS" pitchFamily="34" charset="-120"/>
               </a:rPr>
-              <a:t>Und sonst so</a:t>
+              <a:t>Wir suchen Verstärkung</a:t>
             </a:r>
             <a:endParaRPr lang="en-US" sz="3200" dirty="0"/>
           </a:p>
@@ -9805,7 +9898,7 @@
                 <a:ea typeface="Calibri" pitchFamily="34" charset="-122"/>
                 <a:cs typeface="Calibri" pitchFamily="34" charset="-120"/>
               </a:rPr>
-              <a:t>Vier Dinge zum Mitnehmen - und ein Termin, den ihr euch merken solltet.</a:t>
+              <a:t>Und ihr seid dabei unser bester Kanal - besser als jede Anzeige.</a:t>
             </a:r>
             <a:endParaRPr lang="en-US" sz="1400" dirty="0"/>
           </a:p>
@@ -9819,16 +9912,16 @@
         </p:nvSpPr>
         <p:spPr>
           <a:xfrm>
-            <a:off x="566928" y="1847088"/>
-            <a:ext cx="5372100" cy="2011680"/>
+            <a:off x="566928" y="1828800"/>
+            <a:ext cx="5372100" cy="2240280"/>
           </a:xfrm>
           <a:prstGeom prst="roundRect">
             <a:avLst>
-              <a:gd name="adj" fmla="val 4091"/>
+              <a:gd name="adj" fmla="val 3673"/>
             </a:avLst>
           </a:prstGeom>
           <a:solidFill>
-            <a:srgbClr val="2E7D3A"/>
+            <a:srgbClr val="1A1819"/>
           </a:solidFill>
           <a:ln/>
         </p:spPr>
@@ -9841,7 +9934,7 @@
         </p:nvSpPr>
         <p:spPr>
           <a:xfrm>
-            <a:off x="877824" y="2029968"/>
+            <a:off x="877824" y="2011680"/>
             <a:ext cx="4206240" cy="256032"/>
           </a:xfrm>
           <a:prstGeom prst="rect">
@@ -9866,7 +9959,7 @@
                 <a:ea typeface="Calibri" pitchFamily="34" charset="-122"/>
                 <a:cs typeface="Calibri" pitchFamily="34" charset="-120"/>
               </a:rPr>
-              <a:t>SAVE THE DATE</a:t>
+              <a:t>OFFENE STELLE</a:t>
             </a:r>
             <a:endParaRPr lang="en-US" sz="1050" dirty="0"/>
           </a:p>
@@ -9880,24 +9973,27 @@
         </p:nvSpPr>
         <p:spPr>
           <a:xfrm>
-            <a:off x="877824" y="2322576"/>
-            <a:ext cx="4750308" cy="548640"/>
-          </a:xfrm>
-          <a:prstGeom prst="rect">
-            <a:avLst/>
-          </a:prstGeom>
-          <a:noFill/>
-          <a:ln/>
-        </p:spPr>
-        <p:txBody>
-          <a:bodyPr wrap="square" lIns="0" tIns="0" rIns="0" bIns="0" rtlCol="0" anchor="ctr"/>
-          <a:lstStyle/>
-          <a:p>
-            <a:pPr indent="0" marL="0">
-              <a:buNone/>
-            </a:pPr>
-            <a:r>
-              <a:rPr lang="en-US" sz="3000" b="1" dirty="0">
+            <a:off x="877824" y="2286000"/>
+            <a:ext cx="4750308" cy="1133856"/>
+          </a:xfrm>
+          <a:prstGeom prst="rect">
+            <a:avLst/>
+          </a:prstGeom>
+          <a:noFill/>
+          <a:ln/>
+        </p:spPr>
+        <p:txBody>
+          <a:bodyPr wrap="square" lIns="0" tIns="0" rIns="0" bIns="0" rtlCol="0" anchor="t"/>
+          <a:lstStyle/>
+          <a:p>
+            <a:pPr indent="0" marL="0">
+              <a:lnSpc>
+                <a:spcPts val="4100"/>
+              </a:lnSpc>
+              <a:buNone/>
+            </a:pPr>
+            <a:r>
+              <a:rPr lang="en-US" sz="3400" b="1" dirty="0">
                 <a:solidFill>
                   <a:srgbClr val="FFFFFF"/>
                 </a:solidFill>
@@ -9905,765 +10001,234 @@
                 <a:ea typeface="Trebuchet MS" pitchFamily="34" charset="-122"/>
                 <a:cs typeface="Trebuchet MS" pitchFamily="34" charset="-120"/>
               </a:rPr>
-              <a:t>After Five Grillen</a:t>
-            </a:r>
-            <a:endParaRPr lang="en-US" sz="3000" dirty="0"/>
-          </a:p>
-        </p:txBody>
-      </p:sp>
-      <p:sp>
-        <p:nvSpPr>
-          <p:cNvPr id="8" name="Shape 6"/>
-          <p:cNvSpPr/>
-          <p:nvPr/>
-        </p:nvSpPr>
-        <p:spPr>
-          <a:xfrm>
-            <a:off x="877824" y="2962656"/>
-            <a:ext cx="2011680" cy="457200"/>
-          </a:xfrm>
-          <a:prstGeom prst="roundRect">
-            <a:avLst>
-              <a:gd name="adj" fmla="val 50000"/>
-            </a:avLst>
-          </a:prstGeom>
-          <a:solidFill>
-            <a:srgbClr val="FFFFFF"/>
-          </a:solidFill>
-          <a:ln/>
-        </p:spPr>
-      </p:sp>
-      <p:sp>
-        <p:nvSpPr>
-          <p:cNvPr id="9" name="Text 7"/>
-          <p:cNvSpPr/>
-          <p:nvPr/>
-        </p:nvSpPr>
-        <p:spPr>
-          <a:xfrm>
-            <a:off x="877824" y="2962656"/>
-            <a:ext cx="2011680" cy="457200"/>
-          </a:xfrm>
-          <a:prstGeom prst="rect">
-            <a:avLst/>
-          </a:prstGeom>
-          <a:noFill/>
-          <a:ln/>
-        </p:spPr>
-        <p:txBody>
-          <a:bodyPr wrap="square" lIns="0" tIns="0" rIns="0" bIns="0" rtlCol="0" anchor="ctr"/>
-          <a:lstStyle/>
-          <a:p>
-            <a:pPr algn="ctr" indent="0" marL="0">
-              <a:buNone/>
-            </a:pPr>
-            <a:r>
-              <a:rPr lang="en-US" sz="1250" b="1" dirty="0">
-                <a:solidFill>
-                  <a:srgbClr val="2E7D3A"/>
-                </a:solidFill>
-                <a:latin typeface="Calibri" pitchFamily="34" charset="0"/>
-                <a:ea typeface="Calibri" pitchFamily="34" charset="-122"/>
-                <a:cs typeface="Calibri" pitchFamily="34" charset="-120"/>
-              </a:rPr>
-              <a:t>im September</a:t>
-            </a:r>
-            <a:endParaRPr lang="en-US" sz="1250" dirty="0"/>
-          </a:p>
-        </p:txBody>
-      </p:sp>
-      <p:sp>
-        <p:nvSpPr>
-          <p:cNvPr id="10" name="Text 8"/>
-          <p:cNvSpPr/>
-          <p:nvPr/>
-        </p:nvSpPr>
-        <p:spPr>
-          <a:xfrm>
-            <a:off x="877824" y="3474720"/>
-            <a:ext cx="4750308" cy="365760"/>
-          </a:xfrm>
-          <a:prstGeom prst="rect">
-            <a:avLst/>
-          </a:prstGeom>
-          <a:noFill/>
-          <a:ln/>
-        </p:spPr>
-        <p:txBody>
-          <a:bodyPr wrap="square" lIns="0" tIns="0" rIns="0" bIns="0" rtlCol="0" anchor="t"/>
-          <a:lstStyle/>
+              <a:t>Handwerker /</a:t>
+            </a:r>
+            <a:endParaRPr lang="en-US" sz="3400" dirty="0"/>
+          </a:p>
           <a:p>
             <a:pPr indent="0" marL="0">
               <a:lnSpc>
-                <a:spcPts val="1600"/>
+                <a:spcPts val="4100"/>
               </a:lnSpc>
               <a:buNone/>
             </a:pPr>
             <a:r>
-              <a:rPr lang="en-US" sz="1200" dirty="0">
-                <a:solidFill>
-                  <a:srgbClr val="E4EDE5"/>
-                </a:solidFill>
-                <a:latin typeface="Calibri" pitchFamily="34" charset="0"/>
-                <a:ea typeface="Calibri" pitchFamily="34" charset="-122"/>
-                <a:cs typeface="Calibri" pitchFamily="34" charset="-120"/>
-              </a:rPr>
-              <a:t>Genauer Termin folgt. Haltet euch die Abende im September frei - es lohnt sich.</a:t>
-            </a:r>
-            <a:endParaRPr lang="en-US" sz="1200" dirty="0"/>
-          </a:p>
-        </p:txBody>
-      </p:sp>
-      <p:sp>
-        <p:nvSpPr>
-          <p:cNvPr id="11" name="Shape 9"/>
-          <p:cNvSpPr/>
-          <p:nvPr/>
-        </p:nvSpPr>
-        <p:spPr>
-          <a:xfrm>
-            <a:off x="6249924" y="1847088"/>
-            <a:ext cx="5372100" cy="621792"/>
-          </a:xfrm>
-          <a:prstGeom prst="roundRect">
-            <a:avLst>
-              <a:gd name="adj" fmla="val 10294"/>
-            </a:avLst>
-          </a:prstGeom>
-          <a:solidFill>
-            <a:srgbClr val="F5F6F3"/>
-          </a:solidFill>
-          <a:ln/>
-        </p:spPr>
-      </p:sp>
-      <p:sp>
-        <p:nvSpPr>
-          <p:cNvPr id="12" name="Shape 10"/>
-          <p:cNvSpPr/>
-          <p:nvPr/>
-        </p:nvSpPr>
-        <p:spPr>
-          <a:xfrm>
-            <a:off x="6469380" y="1993392"/>
-            <a:ext cx="329184" cy="329184"/>
-          </a:xfrm>
-          <a:prstGeom prst="ellipse">
-            <a:avLst/>
-          </a:prstGeom>
-          <a:solidFill>
-            <a:srgbClr val="58B264"/>
-          </a:solidFill>
-          <a:ln/>
-        </p:spPr>
-      </p:sp>
-      <p:sp>
-        <p:nvSpPr>
-          <p:cNvPr id="13" name="Text 11"/>
-          <p:cNvSpPr/>
-          <p:nvPr/>
-        </p:nvSpPr>
-        <p:spPr>
-          <a:xfrm>
-            <a:off x="6469380" y="1993392"/>
-            <a:ext cx="329184" cy="329184"/>
-          </a:xfrm>
-          <a:prstGeom prst="rect">
-            <a:avLst/>
-          </a:prstGeom>
-          <a:noFill/>
-          <a:ln/>
-        </p:spPr>
-        <p:txBody>
-          <a:bodyPr wrap="square" lIns="0" tIns="0" rIns="0" bIns="0" rtlCol="0" anchor="ctr"/>
-          <a:lstStyle/>
-          <a:p>
-            <a:pPr algn="ctr" indent="0" marL="0">
-              <a:buNone/>
-            </a:pPr>
-            <a:r>
-              <a:rPr lang="en-US" sz="1200" b="1" dirty="0">
+              <a:rPr lang="en-US" sz="3400" b="1" dirty="0">
                 <a:solidFill>
                   <a:srgbClr val="FFFFFF"/>
-                </a:solidFill>
-                <a:latin typeface="Calibri" pitchFamily="34" charset="0"/>
-                <a:ea typeface="Calibri" pitchFamily="34" charset="-122"/>
-                <a:cs typeface="Calibri" pitchFamily="34" charset="-120"/>
-              </a:rPr>
-              <a:t>1</a:t>
-            </a:r>
-            <a:endParaRPr lang="en-US" sz="1200" dirty="0"/>
-          </a:p>
-        </p:txBody>
-      </p:sp>
-      <p:sp>
-        <p:nvSpPr>
-          <p:cNvPr id="14" name="Text 12"/>
-          <p:cNvSpPr/>
-          <p:nvPr/>
-        </p:nvSpPr>
-        <p:spPr>
-          <a:xfrm>
-            <a:off x="6908292" y="1883664"/>
-            <a:ext cx="4494276" cy="274320"/>
-          </a:xfrm>
-          <a:prstGeom prst="rect">
-            <a:avLst/>
-          </a:prstGeom>
-          <a:noFill/>
-          <a:ln/>
-        </p:spPr>
-        <p:txBody>
-          <a:bodyPr wrap="square" lIns="0" tIns="0" rIns="0" bIns="0" rtlCol="0" anchor="ctr"/>
-          <a:lstStyle/>
-          <a:p>
-            <a:pPr indent="0" marL="0">
-              <a:buNone/>
-            </a:pPr>
-            <a:r>
-              <a:rPr lang="en-US" sz="1350" b="1" dirty="0">
-                <a:solidFill>
-                  <a:srgbClr val="1A1819"/>
                 </a:solidFill>
                 <a:latin typeface="Trebuchet MS" pitchFamily="34" charset="0"/>
                 <a:ea typeface="Trebuchet MS" pitchFamily="34" charset="-122"/>
                 <a:cs typeface="Trebuchet MS" pitchFamily="34" charset="-120"/>
               </a:rPr>
-              <a:t>JobRad-Inspektion</a:t>
-            </a:r>
-            <a:endParaRPr lang="en-US" sz="1350" dirty="0"/>
-          </a:p>
-        </p:txBody>
-      </p:sp>
-      <p:sp>
-        <p:nvSpPr>
-          <p:cNvPr id="15" name="Text 13"/>
-          <p:cNvSpPr/>
-          <p:nvPr/>
-        </p:nvSpPr>
-        <p:spPr>
-          <a:xfrm>
-            <a:off x="6908292" y="2130552"/>
-            <a:ext cx="4512564" cy="310896"/>
-          </a:xfrm>
-          <a:prstGeom prst="rect">
-            <a:avLst/>
-          </a:prstGeom>
-          <a:noFill/>
-          <a:ln/>
-        </p:spPr>
-        <p:txBody>
-          <a:bodyPr wrap="square" lIns="0" tIns="0" rIns="0" bIns="0" rtlCol="0" anchor="ctr"/>
-          <a:lstStyle/>
-          <a:p>
-            <a:pPr indent="0" marL="0">
-              <a:buNone/>
-            </a:pPr>
-            <a:r>
-              <a:rPr lang="en-US" sz="1050" dirty="0">
-                <a:solidFill>
-                  <a:srgbClr val="5B685D"/>
-                </a:solidFill>
-                <a:latin typeface="Calibri" pitchFamily="34" charset="0"/>
-                <a:ea typeface="Calibri" pitchFamily="34" charset="-122"/>
-                <a:cs typeface="Calibri" pitchFamily="34" charset="-120"/>
-              </a:rPr>
-              <a:t>Rad durchchecken lassen - ist bereits bezahlt.</a:t>
-            </a:r>
-            <a:endParaRPr lang="en-US" sz="1050" dirty="0"/>
-          </a:p>
-        </p:txBody>
-      </p:sp>
-      <p:sp>
-        <p:nvSpPr>
-          <p:cNvPr id="16" name="Shape 14"/>
-          <p:cNvSpPr/>
-          <p:nvPr/>
-        </p:nvSpPr>
-        <p:spPr>
-          <a:xfrm>
-            <a:off x="6249924" y="2542032"/>
-            <a:ext cx="5372100" cy="621792"/>
+              <a:t>Hausmeister</a:t>
+            </a:r>
+            <a:endParaRPr lang="en-US" sz="3400" dirty="0"/>
+          </a:p>
+        </p:txBody>
+      </p:sp>
+      <p:sp>
+        <p:nvSpPr>
+          <p:cNvPr id="8" name="Text 6"/>
+          <p:cNvSpPr/>
+          <p:nvPr/>
+        </p:nvSpPr>
+        <p:spPr>
+          <a:xfrm>
+            <a:off x="877824" y="3474720"/>
+            <a:ext cx="4750308" cy="530352"/>
+          </a:xfrm>
+          <a:prstGeom prst="rect">
+            <a:avLst/>
+          </a:prstGeom>
+          <a:noFill/>
+          <a:ln/>
+        </p:spPr>
+        <p:txBody>
+          <a:bodyPr wrap="square" lIns="0" tIns="0" rIns="0" bIns="0" rtlCol="0" anchor="t"/>
+          <a:lstStyle/>
+          <a:p>
+            <a:pPr indent="0" marL="0">
+              <a:lnSpc>
+                <a:spcPts val="1700"/>
+              </a:lnSpc>
+              <a:buNone/>
+            </a:pPr>
+            <a:r>
+              <a:rPr lang="en-US" sz="1250" dirty="0">
+                <a:solidFill>
+                  <a:srgbClr val="C9D2CA"/>
+                </a:solidFill>
+                <a:latin typeface="Calibri" pitchFamily="34" charset="0"/>
+                <a:ea typeface="Calibri" pitchFamily="34" charset="-122"/>
+                <a:cs typeface="Calibri" pitchFamily="34" charset="-120"/>
+              </a:rPr>
+              <a:t>Jemand, der anpackt, mitdenkt und zuverlässig ist. Handwerkliches Geschick und Führerschein bringt er oder sie mit.</a:t>
+            </a:r>
+            <a:endParaRPr lang="en-US" sz="1250" dirty="0"/>
+          </a:p>
+        </p:txBody>
+      </p:sp>
+      <p:sp>
+        <p:nvSpPr>
+          <p:cNvPr id="9" name="Shape 7"/>
+          <p:cNvSpPr/>
+          <p:nvPr/>
+        </p:nvSpPr>
+        <p:spPr>
+          <a:xfrm>
+            <a:off x="6249924" y="1828800"/>
+            <a:ext cx="5372100" cy="2240280"/>
           </a:xfrm>
           <a:prstGeom prst="roundRect">
             <a:avLst>
-              <a:gd name="adj" fmla="val 10294"/>
+              <a:gd name="adj" fmla="val 3673"/>
             </a:avLst>
           </a:prstGeom>
           <a:solidFill>
-            <a:srgbClr val="F5F6F3"/>
+            <a:srgbClr val="EDF5EE"/>
           </a:solidFill>
           <a:ln/>
         </p:spPr>
       </p:sp>
       <p:sp>
         <p:nvSpPr>
-          <p:cNvPr id="17" name="Shape 15"/>
-          <p:cNvSpPr/>
-          <p:nvPr/>
-        </p:nvSpPr>
-        <p:spPr>
-          <a:xfrm>
-            <a:off x="6469380" y="2688336"/>
-            <a:ext cx="329184" cy="329184"/>
-          </a:xfrm>
-          <a:prstGeom prst="ellipse">
-            <a:avLst/>
-          </a:prstGeom>
-          <a:solidFill>
-            <a:srgbClr val="58B264"/>
-          </a:solidFill>
-          <a:ln/>
-        </p:spPr>
-      </p:sp>
-      <p:sp>
-        <p:nvSpPr>
-          <p:cNvPr id="18" name="Text 16"/>
-          <p:cNvSpPr/>
-          <p:nvPr/>
-        </p:nvSpPr>
-        <p:spPr>
-          <a:xfrm>
-            <a:off x="6469380" y="2688336"/>
-            <a:ext cx="329184" cy="329184"/>
-          </a:xfrm>
-          <a:prstGeom prst="rect">
-            <a:avLst/>
-          </a:prstGeom>
-          <a:noFill/>
-          <a:ln/>
-        </p:spPr>
-        <p:txBody>
-          <a:bodyPr wrap="square" lIns="0" tIns="0" rIns="0" bIns="0" rtlCol="0" anchor="ctr"/>
-          <a:lstStyle/>
-          <a:p>
-            <a:pPr algn="ctr" indent="0" marL="0">
-              <a:buNone/>
-            </a:pPr>
-            <a:r>
-              <a:rPr lang="en-US" sz="1200" b="1" dirty="0">
-                <a:solidFill>
-                  <a:srgbClr val="FFFFFF"/>
-                </a:solidFill>
-                <a:latin typeface="Calibri" pitchFamily="34" charset="0"/>
-                <a:ea typeface="Calibri" pitchFamily="34" charset="-122"/>
-                <a:cs typeface="Calibri" pitchFamily="34" charset="-120"/>
-              </a:rPr>
-              <a:t>2</a:t>
-            </a:r>
-            <a:endParaRPr lang="en-US" sz="1200" dirty="0"/>
-          </a:p>
-        </p:txBody>
-      </p:sp>
-      <p:sp>
-        <p:nvSpPr>
-          <p:cNvPr id="19" name="Text 17"/>
-          <p:cNvSpPr/>
-          <p:nvPr/>
-        </p:nvSpPr>
-        <p:spPr>
-          <a:xfrm>
-            <a:off x="6908292" y="2578608"/>
-            <a:ext cx="4494276" cy="274320"/>
-          </a:xfrm>
-          <a:prstGeom prst="rect">
-            <a:avLst/>
-          </a:prstGeom>
-          <a:noFill/>
-          <a:ln/>
-        </p:spPr>
-        <p:txBody>
-          <a:bodyPr wrap="square" lIns="0" tIns="0" rIns="0" bIns="0" rtlCol="0" anchor="ctr"/>
-          <a:lstStyle/>
-          <a:p>
-            <a:pPr indent="0" marL="0">
-              <a:buNone/>
-            </a:pPr>
-            <a:r>
-              <a:rPr lang="en-US" sz="1350" b="1" dirty="0">
-                <a:solidFill>
-                  <a:srgbClr val="1A1819"/>
+          <p:cNvPr id="10" name="Text 8"/>
+          <p:cNvSpPr/>
+          <p:nvPr/>
+        </p:nvSpPr>
+        <p:spPr>
+          <a:xfrm>
+            <a:off x="6560820" y="2048256"/>
+            <a:ext cx="4750308" cy="402336"/>
+          </a:xfrm>
+          <a:prstGeom prst="rect">
+            <a:avLst/>
+          </a:prstGeom>
+          <a:noFill/>
+          <a:ln/>
+        </p:spPr>
+        <p:txBody>
+          <a:bodyPr wrap="square" lIns="0" tIns="0" rIns="0" bIns="0" rtlCol="0" anchor="ctr"/>
+          <a:lstStyle/>
+          <a:p>
+            <a:pPr indent="0" marL="0">
+              <a:buNone/>
+            </a:pPr>
+            <a:r>
+              <a:rPr lang="en-US" sz="2400" b="1" dirty="0">
+                <a:solidFill>
+                  <a:srgbClr val="2E7D3A"/>
                 </a:solidFill>
                 <a:latin typeface="Trebuchet MS" pitchFamily="34" charset="0"/>
                 <a:ea typeface="Trebuchet MS" pitchFamily="34" charset="-122"/>
                 <a:cs typeface="Trebuchet MS" pitchFamily="34" charset="-120"/>
               </a:rPr>
-              <a:t>Volksbank-Event</a:t>
-            </a:r>
-            <a:endParaRPr lang="en-US" sz="1350" dirty="0"/>
-          </a:p>
-        </p:txBody>
-      </p:sp>
-      <p:sp>
-        <p:nvSpPr>
-          <p:cNvPr id="20" name="Text 18"/>
-          <p:cNvSpPr/>
-          <p:nvPr/>
-        </p:nvSpPr>
-        <p:spPr>
-          <a:xfrm>
-            <a:off x="6908292" y="2825496"/>
-            <a:ext cx="4512564" cy="310896"/>
-          </a:xfrm>
-          <a:prstGeom prst="rect">
-            <a:avLst/>
-          </a:prstGeom>
-          <a:noFill/>
-          <a:ln/>
-        </p:spPr>
-        <p:txBody>
-          <a:bodyPr wrap="square" lIns="0" tIns="0" rIns="0" bIns="0" rtlCol="0" anchor="ctr"/>
-          <a:lstStyle/>
-          <a:p>
-            <a:pPr indent="0" marL="0">
-              <a:buNone/>
-            </a:pPr>
-            <a:r>
-              <a:rPr lang="en-US" sz="1050" dirty="0">
-                <a:solidFill>
-                  <a:srgbClr val="5B685D"/>
-                </a:solidFill>
-                <a:latin typeface="Calibri" pitchFamily="34" charset="0"/>
-                <a:ea typeface="Calibri" pitchFamily="34" charset="-122"/>
-                <a:cs typeface="Calibri" pitchFamily="34" charset="-120"/>
-              </a:rPr>
-              <a:t>Zusagen sind raus. Wer noch mit möchte, kurz melden.</a:t>
-            </a:r>
-            <a:endParaRPr lang="en-US" sz="1050" dirty="0"/>
-          </a:p>
-        </p:txBody>
-      </p:sp>
-      <p:sp>
-        <p:nvSpPr>
-          <p:cNvPr id="21" name="Shape 19"/>
-          <p:cNvSpPr/>
-          <p:nvPr/>
-        </p:nvSpPr>
-        <p:spPr>
-          <a:xfrm>
-            <a:off x="6249924" y="3236976"/>
-            <a:ext cx="5372100" cy="621792"/>
+              <a:t>Kennt ihr jemanden?</a:t>
+            </a:r>
+            <a:endParaRPr lang="en-US" sz="2400" dirty="0"/>
+          </a:p>
+        </p:txBody>
+      </p:sp>
+      <p:sp>
+        <p:nvSpPr>
+          <p:cNvPr id="11" name="Text 9"/>
+          <p:cNvSpPr/>
+          <p:nvPr/>
+        </p:nvSpPr>
+        <p:spPr>
+          <a:xfrm>
+            <a:off x="6597396" y="2542032"/>
+            <a:ext cx="4677156" cy="1389888"/>
+          </a:xfrm>
+          <a:prstGeom prst="rect">
+            <a:avLst/>
+          </a:prstGeom>
+          <a:noFill/>
+          <a:ln/>
+        </p:spPr>
+        <p:txBody>
+          <a:bodyPr wrap="square" lIns="0" tIns="0" rIns="0" bIns="0" rtlCol="0" anchor="t"/>
+          <a:lstStyle/>
+          <a:p>
+            <a:pPr marL="342900" indent="-342900">
+              <a:spcAft>
+                <a:spcPts val="1000"/>
+              </a:spcAft>
+              <a:buSzPct val="100000"/>
+              <a:buChar char="•"/>
+            </a:pPr>
+            <a:r>
+              <a:rPr lang="en-US" sz="1250" dirty="0">
+                <a:solidFill>
+                  <a:srgbClr val="1A1819"/>
+                </a:solidFill>
+                <a:latin typeface="Calibri" pitchFamily="34" charset="0"/>
+                <a:ea typeface="Calibri" pitchFamily="34" charset="-122"/>
+                <a:cs typeface="Calibri" pitchFamily="34" charset="-120"/>
+              </a:rPr>
+              <a:t>Denkt an Nachbarn, ehemalige Kollegen, Handwerker von der Baustelle, Bekannte aus dem Verein.</a:t>
+            </a:r>
+            <a:endParaRPr lang="en-US" sz="1250" dirty="0"/>
+          </a:p>
+          <a:p>
+            <a:pPr marL="342900" indent="-342900">
+              <a:spcAft>
+                <a:spcPts val="1000"/>
+              </a:spcAft>
+              <a:buSzPct val="100000"/>
+              <a:buChar char="•"/>
+            </a:pPr>
+            <a:r>
+              <a:rPr lang="en-US" sz="1250" dirty="0">
+                <a:solidFill>
+                  <a:srgbClr val="1A1819"/>
+                </a:solidFill>
+                <a:latin typeface="Calibri" pitchFamily="34" charset="0"/>
+                <a:ea typeface="Calibri" pitchFamily="34" charset="-122"/>
+                <a:cs typeface="Calibri" pitchFamily="34" charset="-120"/>
+              </a:rPr>
+              <a:t>Eine Empfehlung von euch sagt mehr über einen Menschen aus als jede Bewerbungsmappe.</a:t>
+            </a:r>
+            <a:endParaRPr lang="en-US" sz="1250" dirty="0"/>
+          </a:p>
+          <a:p>
+            <a:pPr marL="342900" indent="-342900">
+              <a:spcAft>
+                <a:spcPts val="1000"/>
+              </a:spcAft>
+              <a:buSzPct val="100000"/>
+              <a:buChar char="•"/>
+            </a:pPr>
+            <a:r>
+              <a:rPr lang="en-US" sz="1250" dirty="0">
+                <a:solidFill>
+                  <a:srgbClr val="1A1819"/>
+                </a:solidFill>
+                <a:latin typeface="Calibri" pitchFamily="34" charset="0"/>
+                <a:ea typeface="Calibri" pitchFamily="34" charset="-122"/>
+                <a:cs typeface="Calibri" pitchFamily="34" charset="-120"/>
+              </a:rPr>
+              <a:t>Es reicht völlig, mir einen Namen und eine Nummer zu geben - den Rest übernehme ich.</a:t>
+            </a:r>
+            <a:endParaRPr lang="en-US" sz="1250" dirty="0"/>
+          </a:p>
+        </p:txBody>
+      </p:sp>
+      <p:sp>
+        <p:nvSpPr>
+          <p:cNvPr id="12" name="Shape 10"/>
+          <p:cNvSpPr/>
+          <p:nvPr/>
+        </p:nvSpPr>
+        <p:spPr>
+          <a:xfrm>
+            <a:off x="566928" y="4279392"/>
+            <a:ext cx="11055096" cy="932688"/>
           </a:xfrm>
           <a:prstGeom prst="roundRect">
             <a:avLst>
-              <a:gd name="adj" fmla="val 10294"/>
-            </a:avLst>
-          </a:prstGeom>
-          <a:solidFill>
-            <a:srgbClr val="F5F6F3"/>
-          </a:solidFill>
-          <a:ln/>
-        </p:spPr>
-      </p:sp>
-      <p:sp>
-        <p:nvSpPr>
-          <p:cNvPr id="22" name="Shape 20"/>
-          <p:cNvSpPr/>
-          <p:nvPr/>
-        </p:nvSpPr>
-        <p:spPr>
-          <a:xfrm>
-            <a:off x="6469380" y="3383280"/>
-            <a:ext cx="329184" cy="329184"/>
-          </a:xfrm>
-          <a:prstGeom prst="ellipse">
-            <a:avLst/>
-          </a:prstGeom>
-          <a:solidFill>
-            <a:srgbClr val="58B264"/>
-          </a:solidFill>
-          <a:ln/>
-        </p:spPr>
-      </p:sp>
-      <p:sp>
-        <p:nvSpPr>
-          <p:cNvPr id="23" name="Text 21"/>
-          <p:cNvSpPr/>
-          <p:nvPr/>
-        </p:nvSpPr>
-        <p:spPr>
-          <a:xfrm>
-            <a:off x="6469380" y="3383280"/>
-            <a:ext cx="329184" cy="329184"/>
-          </a:xfrm>
-          <a:prstGeom prst="rect">
-            <a:avLst/>
-          </a:prstGeom>
-          <a:noFill/>
-          <a:ln/>
-        </p:spPr>
-        <p:txBody>
-          <a:bodyPr wrap="square" lIns="0" tIns="0" rIns="0" bIns="0" rtlCol="0" anchor="ctr"/>
-          <a:lstStyle/>
-          <a:p>
-            <a:pPr algn="ctr" indent="0" marL="0">
-              <a:buNone/>
-            </a:pPr>
-            <a:r>
-              <a:rPr lang="en-US" sz="1200" b="1" dirty="0">
-                <a:solidFill>
-                  <a:srgbClr val="FFFFFF"/>
-                </a:solidFill>
-                <a:latin typeface="Calibri" pitchFamily="34" charset="0"/>
-                <a:ea typeface="Calibri" pitchFamily="34" charset="-122"/>
-                <a:cs typeface="Calibri" pitchFamily="34" charset="-120"/>
-              </a:rPr>
-              <a:t>3</a:t>
-            </a:r>
-            <a:endParaRPr lang="en-US" sz="1200" dirty="0"/>
-          </a:p>
-        </p:txBody>
-      </p:sp>
-      <p:sp>
-        <p:nvSpPr>
-          <p:cNvPr id="24" name="Text 22"/>
-          <p:cNvSpPr/>
-          <p:nvPr/>
-        </p:nvSpPr>
-        <p:spPr>
-          <a:xfrm>
-            <a:off x="6908292" y="3273552"/>
-            <a:ext cx="4494276" cy="274320"/>
-          </a:xfrm>
-          <a:prstGeom prst="rect">
-            <a:avLst/>
-          </a:prstGeom>
-          <a:noFill/>
-          <a:ln/>
-        </p:spPr>
-        <p:txBody>
-          <a:bodyPr wrap="square" lIns="0" tIns="0" rIns="0" bIns="0" rtlCol="0" anchor="ctr"/>
-          <a:lstStyle/>
-          <a:p>
-            <a:pPr indent="0" marL="0">
-              <a:buNone/>
-            </a:pPr>
-            <a:r>
-              <a:rPr lang="en-US" sz="1350" b="1" dirty="0">
-                <a:solidFill>
-                  <a:srgbClr val="1A1819"/>
-                </a:solidFill>
-                <a:latin typeface="Trebuchet MS" pitchFamily="34" charset="0"/>
-                <a:ea typeface="Trebuchet MS" pitchFamily="34" charset="-122"/>
-                <a:cs typeface="Trebuchet MS" pitchFamily="34" charset="-120"/>
-              </a:rPr>
-              <a:t>SC Paderborn</a:t>
-            </a:r>
-            <a:endParaRPr lang="en-US" sz="1350" dirty="0"/>
-          </a:p>
-        </p:txBody>
-      </p:sp>
-      <p:sp>
-        <p:nvSpPr>
-          <p:cNvPr id="25" name="Text 23"/>
-          <p:cNvSpPr/>
-          <p:nvPr/>
-        </p:nvSpPr>
-        <p:spPr>
-          <a:xfrm>
-            <a:off x="6908292" y="3520440"/>
-            <a:ext cx="4512564" cy="310896"/>
-          </a:xfrm>
-          <a:prstGeom prst="rect">
-            <a:avLst/>
-          </a:prstGeom>
-          <a:noFill/>
-          <a:ln/>
-        </p:spPr>
-        <p:txBody>
-          <a:bodyPr wrap="square" lIns="0" tIns="0" rIns="0" bIns="0" rtlCol="0" anchor="ctr"/>
-          <a:lstStyle/>
-          <a:p>
-            <a:pPr indent="0" marL="0">
-              <a:buNone/>
-            </a:pPr>
-            <a:r>
-              <a:rPr lang="en-US" sz="1050" dirty="0">
-                <a:solidFill>
-                  <a:srgbClr val="5B685D"/>
-                </a:solidFill>
-                <a:latin typeface="Calibri" pitchFamily="34" charset="0"/>
-                <a:ea typeface="Calibri" pitchFamily="34" charset="-122"/>
-                <a:cs typeface="Calibri" pitchFamily="34" charset="-120"/>
-              </a:rPr>
-              <a:t>Auswärtsspiel Mainz, VIP-Ticket 270 €. Interesse an Annika.</a:t>
-            </a:r>
-            <a:endParaRPr lang="en-US" sz="1050" dirty="0"/>
-          </a:p>
-        </p:txBody>
-      </p:sp>
-      <p:sp>
-        <p:nvSpPr>
-          <p:cNvPr id="26" name="Shape 24"/>
-          <p:cNvSpPr/>
-          <p:nvPr/>
-        </p:nvSpPr>
-        <p:spPr>
-          <a:xfrm>
-            <a:off x="6249924" y="3931920"/>
-            <a:ext cx="5372100" cy="621792"/>
-          </a:xfrm>
-          <a:prstGeom prst="roundRect">
-            <a:avLst>
-              <a:gd name="adj" fmla="val 10294"/>
-            </a:avLst>
-          </a:prstGeom>
-          <a:solidFill>
-            <a:srgbClr val="EDF5EE"/>
-          </a:solidFill>
-          <a:ln/>
-        </p:spPr>
-      </p:sp>
-      <p:sp>
-        <p:nvSpPr>
-          <p:cNvPr id="27" name="Shape 25"/>
-          <p:cNvSpPr/>
-          <p:nvPr/>
-        </p:nvSpPr>
-        <p:spPr>
-          <a:xfrm>
-            <a:off x="6469380" y="4078224"/>
-            <a:ext cx="329184" cy="329184"/>
-          </a:xfrm>
-          <a:prstGeom prst="ellipse">
-            <a:avLst/>
-          </a:prstGeom>
-          <a:solidFill>
-            <a:srgbClr val="2E7D3A"/>
-          </a:solidFill>
-          <a:ln/>
-        </p:spPr>
-      </p:sp>
-      <p:sp>
-        <p:nvSpPr>
-          <p:cNvPr id="28" name="Text 26"/>
-          <p:cNvSpPr/>
-          <p:nvPr/>
-        </p:nvSpPr>
-        <p:spPr>
-          <a:xfrm>
-            <a:off x="6469380" y="4078224"/>
-            <a:ext cx="329184" cy="329184"/>
-          </a:xfrm>
-          <a:prstGeom prst="rect">
-            <a:avLst/>
-          </a:prstGeom>
-          <a:noFill/>
-          <a:ln/>
-        </p:spPr>
-        <p:txBody>
-          <a:bodyPr wrap="square" lIns="0" tIns="0" rIns="0" bIns="0" rtlCol="0" anchor="ctr"/>
-          <a:lstStyle/>
-          <a:p>
-            <a:pPr algn="ctr" indent="0" marL="0">
-              <a:buNone/>
-            </a:pPr>
-            <a:r>
-              <a:rPr lang="en-US" sz="1200" b="1" dirty="0">
-                <a:solidFill>
-                  <a:srgbClr val="FFFFFF"/>
-                </a:solidFill>
-                <a:latin typeface="Calibri" pitchFamily="34" charset="0"/>
-                <a:ea typeface="Calibri" pitchFamily="34" charset="-122"/>
-                <a:cs typeface="Calibri" pitchFamily="34" charset="-120"/>
-              </a:rPr>
-              <a:t>4</a:t>
-            </a:r>
-            <a:endParaRPr lang="en-US" sz="1200" dirty="0"/>
-          </a:p>
-        </p:txBody>
-      </p:sp>
-      <p:sp>
-        <p:nvSpPr>
-          <p:cNvPr id="29" name="Text 27"/>
-          <p:cNvSpPr/>
-          <p:nvPr/>
-        </p:nvSpPr>
-        <p:spPr>
-          <a:xfrm>
-            <a:off x="6908292" y="3968496"/>
-            <a:ext cx="4494276" cy="274320"/>
-          </a:xfrm>
-          <a:prstGeom prst="rect">
-            <a:avLst/>
-          </a:prstGeom>
-          <a:noFill/>
-          <a:ln/>
-        </p:spPr>
-        <p:txBody>
-          <a:bodyPr wrap="square" lIns="0" tIns="0" rIns="0" bIns="0" rtlCol="0" anchor="ctr"/>
-          <a:lstStyle/>
-          <a:p>
-            <a:pPr indent="0" marL="0">
-              <a:buNone/>
-            </a:pPr>
-            <a:r>
-              <a:rPr lang="en-US" sz="1350" b="1" dirty="0">
-                <a:solidFill>
-                  <a:srgbClr val="1A1819"/>
-                </a:solidFill>
-                <a:latin typeface="Trebuchet MS" pitchFamily="34" charset="0"/>
-                <a:ea typeface="Trebuchet MS" pitchFamily="34" charset="-122"/>
-                <a:cs typeface="Trebuchet MS" pitchFamily="34" charset="-120"/>
-              </a:rPr>
-              <a:t>Neuer Opel Grandland</a:t>
-            </a:r>
-            <a:endParaRPr lang="en-US" sz="1350" dirty="0"/>
-          </a:p>
-        </p:txBody>
-      </p:sp>
-      <p:sp>
-        <p:nvSpPr>
-          <p:cNvPr id="30" name="Text 28"/>
-          <p:cNvSpPr/>
-          <p:nvPr/>
-        </p:nvSpPr>
-        <p:spPr>
-          <a:xfrm>
-            <a:off x="6908292" y="4224528"/>
-            <a:ext cx="4512564" cy="274320"/>
-          </a:xfrm>
-          <a:prstGeom prst="rect">
-            <a:avLst/>
-          </a:prstGeom>
-          <a:noFill/>
-          <a:ln/>
-        </p:spPr>
-        <p:txBody>
-          <a:bodyPr wrap="square" lIns="0" tIns="0" rIns="0" bIns="0" rtlCol="0" anchor="ctr"/>
-          <a:lstStyle/>
-          <a:p>
-            <a:pPr indent="0" marL="0">
-              <a:buNone/>
-            </a:pPr>
-            <a:r>
-              <a:rPr lang="en-US" sz="1050" dirty="0">
-                <a:solidFill>
-                  <a:srgbClr val="5B685D"/>
-                </a:solidFill>
-                <a:latin typeface="Calibri" pitchFamily="34" charset="0"/>
-                <a:ea typeface="Calibri" pitchFamily="34" charset="-122"/>
-                <a:cs typeface="Calibri" pitchFamily="34" charset="-120"/>
-              </a:rPr>
-              <a:t>Ist geliefert. Die Fahrzeugpapiere liegen bei Melissa.</a:t>
-            </a:r>
-            <a:endParaRPr lang="en-US" sz="1050" dirty="0"/>
-          </a:p>
-        </p:txBody>
-      </p:sp>
-      <p:sp>
-        <p:nvSpPr>
-          <p:cNvPr id="31" name="Shape 29"/>
-          <p:cNvSpPr/>
-          <p:nvPr/>
-        </p:nvSpPr>
-        <p:spPr>
-          <a:xfrm>
-            <a:off x="566928" y="4224528"/>
-            <a:ext cx="5372100" cy="1481328"/>
-          </a:xfrm>
-          <a:prstGeom prst="roundRect">
-            <a:avLst>
-              <a:gd name="adj" fmla="val 5556"/>
+              <a:gd name="adj" fmla="val 8824"/>
             </a:avLst>
           </a:prstGeom>
           <a:solidFill>
@@ -10681,30 +10246,30 @@
       </p:sp>
       <p:sp>
         <p:nvSpPr>
-          <p:cNvPr id="32" name="Text 30"/>
-          <p:cNvSpPr/>
-          <p:nvPr/>
-        </p:nvSpPr>
-        <p:spPr>
-          <a:xfrm>
-            <a:off x="877824" y="4407408"/>
-            <a:ext cx="4750308" cy="310896"/>
-          </a:xfrm>
-          <a:prstGeom prst="rect">
-            <a:avLst/>
-          </a:prstGeom>
-          <a:noFill/>
-          <a:ln/>
-        </p:spPr>
-        <p:txBody>
-          <a:bodyPr wrap="square" lIns="0" tIns="0" rIns="0" bIns="0" rtlCol="0" anchor="ctr"/>
-          <a:lstStyle/>
-          <a:p>
-            <a:pPr indent="0" marL="0">
-              <a:buNone/>
-            </a:pPr>
-            <a:r>
-              <a:rPr lang="en-US" sz="1600" b="1" dirty="0">
+          <p:cNvPr id="13" name="Text 11"/>
+          <p:cNvSpPr/>
+          <p:nvPr/>
+        </p:nvSpPr>
+        <p:spPr>
+          <a:xfrm>
+            <a:off x="877824" y="4389120"/>
+            <a:ext cx="10433304" cy="274320"/>
+          </a:xfrm>
+          <a:prstGeom prst="rect">
+            <a:avLst/>
+          </a:prstGeom>
+          <a:noFill/>
+          <a:ln/>
+        </p:spPr>
+        <p:txBody>
+          <a:bodyPr wrap="square" lIns="0" tIns="0" rIns="0" bIns="0" rtlCol="0" anchor="ctr"/>
+          <a:lstStyle/>
+          <a:p>
+            <a:pPr indent="0" marL="0">
+              <a:buNone/>
+            </a:pPr>
+            <a:r>
+              <a:rPr lang="en-US" sz="1500" b="1" dirty="0">
                 <a:solidFill>
                   <a:srgbClr val="2E7D3A"/>
                 </a:solidFill>
@@ -10712,22 +10277,22 @@
                 <a:ea typeface="Trebuchet MS" pitchFamily="34" charset="-122"/>
                 <a:cs typeface="Trebuchet MS" pitchFamily="34" charset="-120"/>
               </a:rPr>
-              <a:t>Fragen, Anliegen, Ideen?</a:t>
-            </a:r>
-            <a:endParaRPr lang="en-US" sz="1600" dirty="0"/>
-          </a:p>
-        </p:txBody>
-      </p:sp>
-      <p:sp>
-        <p:nvSpPr>
-          <p:cNvPr id="33" name="Text 31"/>
-          <p:cNvSpPr/>
-          <p:nvPr/>
-        </p:nvSpPr>
-        <p:spPr>
-          <a:xfrm>
-            <a:off x="896112" y="4773168"/>
-            <a:ext cx="4713732" cy="786384"/>
+              <a:t>Warum jetzt</a:t>
+            </a:r>
+            <a:endParaRPr lang="en-US" sz="1500" dirty="0"/>
+          </a:p>
+        </p:txBody>
+      </p:sp>
+      <p:sp>
+        <p:nvSpPr>
+          <p:cNvPr id="14" name="Text 12"/>
+          <p:cNvSpPr/>
+          <p:nvPr/>
+        </p:nvSpPr>
+        <p:spPr>
+          <a:xfrm>
+            <a:off x="877824" y="4663440"/>
+            <a:ext cx="10433304" cy="438912"/>
           </a:xfrm>
           <a:prstGeom prst="rect">
             <a:avLst/>
@@ -10741,7 +10306,7 @@
           <a:p>
             <a:pPr indent="0" marL="0">
               <a:lnSpc>
-                <a:spcPts val="1700"/>
+                <a:spcPts val="1600"/>
               </a:lnSpc>
               <a:buNone/>
             </a:pPr>
@@ -10754,7 +10319,7 @@
                 <a:ea typeface="Calibri" pitchFamily="34" charset="-122"/>
                 <a:cs typeface="Calibri" pitchFamily="34" charset="-120"/>
               </a:rPr>
-              <a:t>Meine Tür steht offen, und über den Buchungskalender könnt ihr euch jederzeit selbst einen Termin bei mir legen. Kein Anlass ist dafür zu klein.</a:t>
+              <a:t>Wir wachsen - mit Kassel, mit Dortmund ab Oktober und mit immer mehr Objekten, die betreut werden wollen. Vieles davon erledigen wir bisher nebenher. Das soll jemand machen, der es richtig kann.</a:t>
             </a:r>
             <a:endParaRPr lang="en-US" sz="1250" dirty="0"/>
           </a:p>
@@ -10762,7 +10327,87 @@
       </p:sp>
       <p:sp>
         <p:nvSpPr>
-          <p:cNvPr id="35" name="Text 32"/>
+          <p:cNvPr id="15" name="Shape 13"/>
+          <p:cNvSpPr/>
+          <p:nvPr/>
+        </p:nvSpPr>
+        <p:spPr>
+          <a:xfrm>
+            <a:off x="566928" y="5431536"/>
+            <a:ext cx="11055096" cy="621792"/>
+          </a:xfrm>
+          <a:prstGeom prst="roundRect">
+            <a:avLst>
+              <a:gd name="adj" fmla="val 13235"/>
+            </a:avLst>
+          </a:prstGeom>
+          <a:solidFill>
+            <a:srgbClr val="FFF6E0"/>
+          </a:solidFill>
+          <a:ln w="12700">
+            <a:solidFill>
+              <a:srgbClr val="E8CC8A"/>
+            </a:solidFill>
+            <a:prstDash val="solid"/>
+          </a:ln>
+        </p:spPr>
+      </p:sp>
+      <p:sp>
+        <p:nvSpPr>
+          <p:cNvPr id="16" name="Text 14"/>
+          <p:cNvSpPr/>
+          <p:nvPr/>
+        </p:nvSpPr>
+        <p:spPr>
+          <a:xfrm>
+            <a:off x="768096" y="5486400"/>
+            <a:ext cx="10652760" cy="512064"/>
+          </a:xfrm>
+          <a:prstGeom prst="rect">
+            <a:avLst/>
+          </a:prstGeom>
+          <a:noFill/>
+          <a:ln/>
+        </p:spPr>
+        <p:txBody>
+          <a:bodyPr wrap="square" lIns="0" tIns="0" rIns="0" bIns="0" rtlCol="0" anchor="ctr"/>
+          <a:lstStyle/>
+          <a:p>
+            <a:pPr indent="0" marL="0">
+              <a:buNone/>
+            </a:pPr>
+            <a:r>
+              <a:rPr lang="en-US" sz="1200" b="1" dirty="0">
+                <a:solidFill>
+                  <a:srgbClr val="8A6100"/>
+                </a:solidFill>
+                <a:latin typeface="Calibri" pitchFamily="34" charset="0"/>
+                <a:ea typeface="Calibri" pitchFamily="34" charset="-122"/>
+                <a:cs typeface="Calibri" pitchFamily="34" charset="-120"/>
+              </a:rPr>
+              <a:t>So geht's:  </a:t>
+            </a:r>
+            <a:pPr indent="0" marL="0">
+              <a:buNone/>
+            </a:pPr>
+            <a:r>
+              <a:rPr lang="en-US" sz="1200" dirty="0">
+                <a:solidFill>
+                  <a:srgbClr val="1A1819"/>
+                </a:solidFill>
+                <a:latin typeface="Calibri" pitchFamily="34" charset="0"/>
+                <a:ea typeface="Calibri" pitchFamily="34" charset="-122"/>
+                <a:cs typeface="Calibri" pitchFamily="34" charset="-120"/>
+              </a:rPr>
+              <a:t>Sprecht mich direkt an oder schreibt mir kurz in Teams. Auch ein „Ich frage mal rum" hilft schon - Hauptsache, es bleibt nicht bei einem Nicken hier im Raum.</a:t>
+            </a:r>
+            <a:endParaRPr lang="en-US" sz="1200" dirty="0"/>
+          </a:p>
+        </p:txBody>
+      </p:sp>
+      <p:sp>
+        <p:nvSpPr>
+          <p:cNvPr id="18" name="Text 15"/>
           <p:cNvSpPr/>
           <p:nvPr/>
         </p:nvSpPr>
@@ -10793,7 +10438,7 @@
                 <a:ea typeface="Calibri" pitchFamily="34" charset="-122"/>
                 <a:cs typeface="Calibri" pitchFamily="34" charset="-120"/>
               </a:rPr>
-              <a:t>Stand 06.08.2026</a:t>
+              <a:t>Meldet euch gerne auch nach dem Meeting</a:t>
             </a:r>
             <a:endParaRPr lang="en-US" sz="900" dirty="0"/>
           </a:p>
@@ -11489,7 +11134,27 @@
                 <a:ea typeface="Calibri" pitchFamily="34" charset="-122"/>
                 <a:cs typeface="Calibri" pitchFamily="34" charset="-120"/>
               </a:rPr>
-              <a:t>Code of Conduct, Personelles und was ansteht</a:t>
+              <a:t>Code of Conduct, Personelles, wen wir suchen</a:t>
+            </a:r>
+            <a:endParaRPr lang="en-US" sz="1250" dirty="0"/>
+          </a:p>
+          <a:p>
+            <a:pPr indent="0" marL="0">
+              <a:lnSpc>
+                <a:spcPts val="1600"/>
+              </a:lnSpc>
+              <a:buNone/>
+            </a:pPr>
+            <a:r>
+              <a:rPr lang="en-US" sz="1250" dirty="0">
+                <a:solidFill>
+                  <a:srgbClr val="5B685D"/>
+                </a:solidFill>
+                <a:latin typeface="Calibri" pitchFamily="34" charset="0"/>
+                <a:ea typeface="Calibri" pitchFamily="34" charset="-122"/>
+                <a:cs typeface="Calibri" pitchFamily="34" charset="-120"/>
+              </a:rPr>
+              <a:t>und was in den nächsten Wochen ansteht</a:t>
             </a:r>
             <a:endParaRPr lang="en-US" sz="1250" dirty="0"/>
           </a:p>
@@ -11584,6 +11249,1143 @@
 <file path=ppt/slides/slide20.xml><?xml version="1.0" encoding="utf-8"?>
 <p:sld xmlns:a="http://schemas.openxmlformats.org/drawingml/2006/main" xmlns:r="http://schemas.openxmlformats.org/officeDocument/2006/relationships" xmlns:p="http://schemas.openxmlformats.org/presentationml/2006/main">
   <p:cSld name="Slide 20">
+    <p:bg>
+      <p:bgPr>
+        <a:solidFill>
+          <a:srgbClr val="FFFFFF"/>
+        </a:solidFill>
+      </p:bgPr>
+    </p:bg>
+    <p:spTree>
+      <p:nvGrpSpPr>
+        <p:cNvPr id="1" name=""/>
+        <p:cNvGrpSpPr/>
+        <p:nvPr/>
+      </p:nvGrpSpPr>
+      <p:grpSpPr>
+        <a:xfrm>
+          <a:off x="0" y="0"/>
+          <a:ext cx="0" cy="0"/>
+          <a:chOff x="0" y="0"/>
+          <a:chExt cx="0" cy="0"/>
+        </a:xfrm>
+      </p:grpSpPr>
+      <p:sp>
+        <p:nvSpPr>
+          <p:cNvPr id="2" name="Text 0"/>
+          <p:cNvSpPr/>
+          <p:nvPr/>
+        </p:nvSpPr>
+        <p:spPr>
+          <a:xfrm>
+            <a:off x="566928" y="365760"/>
+            <a:ext cx="11055096" cy="237744"/>
+          </a:xfrm>
+          <a:prstGeom prst="rect">
+            <a:avLst/>
+          </a:prstGeom>
+          <a:noFill/>
+          <a:ln/>
+        </p:spPr>
+        <p:txBody>
+          <a:bodyPr wrap="square" lIns="0" tIns="0" rIns="0" bIns="0" rtlCol="0" anchor="ctr"/>
+          <a:lstStyle/>
+          <a:p>
+            <a:pPr indent="0" marL="0">
+              <a:buNone/>
+            </a:pPr>
+            <a:r>
+              <a:rPr lang="en-US" sz="1100" b="1" spc="160" kern="0" dirty="0">
+                <a:solidFill>
+                  <a:srgbClr val="2E7D3A"/>
+                </a:solidFill>
+                <a:latin typeface="Calibri" pitchFamily="34" charset="0"/>
+                <a:ea typeface="Calibri" pitchFamily="34" charset="-122"/>
+                <a:cs typeface="Calibri" pitchFamily="34" charset="-120"/>
+              </a:rPr>
+              <a:t>KAPITEL 3 · TERMINE</a:t>
+            </a:r>
+            <a:endParaRPr lang="en-US" sz="1100" dirty="0"/>
+          </a:p>
+        </p:txBody>
+      </p:sp>
+      <p:sp>
+        <p:nvSpPr>
+          <p:cNvPr id="3" name="Text 1"/>
+          <p:cNvSpPr/>
+          <p:nvPr/>
+        </p:nvSpPr>
+        <p:spPr>
+          <a:xfrm>
+            <a:off x="566928" y="621792"/>
+            <a:ext cx="11055096" cy="658368"/>
+          </a:xfrm>
+          <a:prstGeom prst="rect">
+            <a:avLst/>
+          </a:prstGeom>
+          <a:noFill/>
+          <a:ln/>
+        </p:spPr>
+        <p:txBody>
+          <a:bodyPr wrap="square" lIns="0" tIns="0" rIns="0" bIns="0" rtlCol="0" anchor="ctr"/>
+          <a:lstStyle/>
+          <a:p>
+            <a:pPr indent="0" marL="0">
+              <a:buNone/>
+            </a:pPr>
+            <a:r>
+              <a:rPr lang="en-US" sz="3200" b="1" dirty="0">
+                <a:solidFill>
+                  <a:srgbClr val="1A1819"/>
+                </a:solidFill>
+                <a:latin typeface="Trebuchet MS" pitchFamily="34" charset="0"/>
+                <a:ea typeface="Trebuchet MS" pitchFamily="34" charset="-122"/>
+                <a:cs typeface="Trebuchet MS" pitchFamily="34" charset="-120"/>
+              </a:rPr>
+              <a:t>Und sonst so</a:t>
+            </a:r>
+            <a:endParaRPr lang="en-US" sz="3200" dirty="0"/>
+          </a:p>
+        </p:txBody>
+      </p:sp>
+      <p:sp>
+        <p:nvSpPr>
+          <p:cNvPr id="4" name="Text 2"/>
+          <p:cNvSpPr/>
+          <p:nvPr/>
+        </p:nvSpPr>
+        <p:spPr>
+          <a:xfrm>
+            <a:off x="566928" y="1280160"/>
+            <a:ext cx="11055096" cy="310896"/>
+          </a:xfrm>
+          <a:prstGeom prst="rect">
+            <a:avLst/>
+          </a:prstGeom>
+          <a:noFill/>
+          <a:ln/>
+        </p:spPr>
+        <p:txBody>
+          <a:bodyPr wrap="square" lIns="0" tIns="0" rIns="0" bIns="0" rtlCol="0" anchor="ctr"/>
+          <a:lstStyle/>
+          <a:p>
+            <a:pPr indent="0" marL="0">
+              <a:buNone/>
+            </a:pPr>
+            <a:r>
+              <a:rPr lang="en-US" sz="1400" dirty="0">
+                <a:solidFill>
+                  <a:srgbClr val="5B685D"/>
+                </a:solidFill>
+                <a:latin typeface="Calibri" pitchFamily="34" charset="0"/>
+                <a:ea typeface="Calibri" pitchFamily="34" charset="-122"/>
+                <a:cs typeface="Calibri" pitchFamily="34" charset="-120"/>
+              </a:rPr>
+              <a:t>Vier Dinge zum Mitnehmen - und ein Termin, den ihr euch merken solltet.</a:t>
+            </a:r>
+            <a:endParaRPr lang="en-US" sz="1400" dirty="0"/>
+          </a:p>
+        </p:txBody>
+      </p:sp>
+      <p:sp>
+        <p:nvSpPr>
+          <p:cNvPr id="5" name="Shape 3"/>
+          <p:cNvSpPr/>
+          <p:nvPr/>
+        </p:nvSpPr>
+        <p:spPr>
+          <a:xfrm>
+            <a:off x="566928" y="1847088"/>
+            <a:ext cx="5372100" cy="2011680"/>
+          </a:xfrm>
+          <a:prstGeom prst="roundRect">
+            <a:avLst>
+              <a:gd name="adj" fmla="val 4091"/>
+            </a:avLst>
+          </a:prstGeom>
+          <a:solidFill>
+            <a:srgbClr val="2E7D3A"/>
+          </a:solidFill>
+          <a:ln/>
+        </p:spPr>
+      </p:sp>
+      <p:sp>
+        <p:nvSpPr>
+          <p:cNvPr id="6" name="Text 4"/>
+          <p:cNvSpPr/>
+          <p:nvPr/>
+        </p:nvSpPr>
+        <p:spPr>
+          <a:xfrm>
+            <a:off x="877824" y="2029968"/>
+            <a:ext cx="4206240" cy="256032"/>
+          </a:xfrm>
+          <a:prstGeom prst="rect">
+            <a:avLst/>
+          </a:prstGeom>
+          <a:noFill/>
+          <a:ln/>
+        </p:spPr>
+        <p:txBody>
+          <a:bodyPr wrap="square" lIns="0" tIns="0" rIns="0" bIns="0" rtlCol="0" anchor="ctr"/>
+          <a:lstStyle/>
+          <a:p>
+            <a:pPr indent="0" marL="0">
+              <a:buNone/>
+            </a:pPr>
+            <a:r>
+              <a:rPr lang="en-US" sz="1050" b="1" spc="160" kern="0" dirty="0">
+                <a:solidFill>
+                  <a:srgbClr val="BFDCC4"/>
+                </a:solidFill>
+                <a:latin typeface="Calibri" pitchFamily="34" charset="0"/>
+                <a:ea typeface="Calibri" pitchFamily="34" charset="-122"/>
+                <a:cs typeface="Calibri" pitchFamily="34" charset="-120"/>
+              </a:rPr>
+              <a:t>SAVE THE DATE</a:t>
+            </a:r>
+            <a:endParaRPr lang="en-US" sz="1050" dirty="0"/>
+          </a:p>
+        </p:txBody>
+      </p:sp>
+      <p:sp>
+        <p:nvSpPr>
+          <p:cNvPr id="7" name="Text 5"/>
+          <p:cNvSpPr/>
+          <p:nvPr/>
+        </p:nvSpPr>
+        <p:spPr>
+          <a:xfrm>
+            <a:off x="877824" y="2322576"/>
+            <a:ext cx="4750308" cy="548640"/>
+          </a:xfrm>
+          <a:prstGeom prst="rect">
+            <a:avLst/>
+          </a:prstGeom>
+          <a:noFill/>
+          <a:ln/>
+        </p:spPr>
+        <p:txBody>
+          <a:bodyPr wrap="square" lIns="0" tIns="0" rIns="0" bIns="0" rtlCol="0" anchor="ctr"/>
+          <a:lstStyle/>
+          <a:p>
+            <a:pPr indent="0" marL="0">
+              <a:buNone/>
+            </a:pPr>
+            <a:r>
+              <a:rPr lang="en-US" sz="3000" b="1" dirty="0">
+                <a:solidFill>
+                  <a:srgbClr val="FFFFFF"/>
+                </a:solidFill>
+                <a:latin typeface="Trebuchet MS" pitchFamily="34" charset="0"/>
+                <a:ea typeface="Trebuchet MS" pitchFamily="34" charset="-122"/>
+                <a:cs typeface="Trebuchet MS" pitchFamily="34" charset="-120"/>
+              </a:rPr>
+              <a:t>After Five Grillen</a:t>
+            </a:r>
+            <a:endParaRPr lang="en-US" sz="3000" dirty="0"/>
+          </a:p>
+        </p:txBody>
+      </p:sp>
+      <p:sp>
+        <p:nvSpPr>
+          <p:cNvPr id="8" name="Shape 6"/>
+          <p:cNvSpPr/>
+          <p:nvPr/>
+        </p:nvSpPr>
+        <p:spPr>
+          <a:xfrm>
+            <a:off x="877824" y="2962656"/>
+            <a:ext cx="2011680" cy="457200"/>
+          </a:xfrm>
+          <a:prstGeom prst="roundRect">
+            <a:avLst>
+              <a:gd name="adj" fmla="val 50000"/>
+            </a:avLst>
+          </a:prstGeom>
+          <a:solidFill>
+            <a:srgbClr val="FFFFFF"/>
+          </a:solidFill>
+          <a:ln/>
+        </p:spPr>
+      </p:sp>
+      <p:sp>
+        <p:nvSpPr>
+          <p:cNvPr id="9" name="Text 7"/>
+          <p:cNvSpPr/>
+          <p:nvPr/>
+        </p:nvSpPr>
+        <p:spPr>
+          <a:xfrm>
+            <a:off x="877824" y="2962656"/>
+            <a:ext cx="2011680" cy="457200"/>
+          </a:xfrm>
+          <a:prstGeom prst="rect">
+            <a:avLst/>
+          </a:prstGeom>
+          <a:noFill/>
+          <a:ln/>
+        </p:spPr>
+        <p:txBody>
+          <a:bodyPr wrap="square" lIns="0" tIns="0" rIns="0" bIns="0" rtlCol="0" anchor="ctr"/>
+          <a:lstStyle/>
+          <a:p>
+            <a:pPr algn="ctr" indent="0" marL="0">
+              <a:buNone/>
+            </a:pPr>
+            <a:r>
+              <a:rPr lang="en-US" sz="1250" b="1" dirty="0">
+                <a:solidFill>
+                  <a:srgbClr val="2E7D3A"/>
+                </a:solidFill>
+                <a:latin typeface="Calibri" pitchFamily="34" charset="0"/>
+                <a:ea typeface="Calibri" pitchFamily="34" charset="-122"/>
+                <a:cs typeface="Calibri" pitchFamily="34" charset="-120"/>
+              </a:rPr>
+              <a:t>im September</a:t>
+            </a:r>
+            <a:endParaRPr lang="en-US" sz="1250" dirty="0"/>
+          </a:p>
+        </p:txBody>
+      </p:sp>
+      <p:sp>
+        <p:nvSpPr>
+          <p:cNvPr id="10" name="Text 8"/>
+          <p:cNvSpPr/>
+          <p:nvPr/>
+        </p:nvSpPr>
+        <p:spPr>
+          <a:xfrm>
+            <a:off x="877824" y="3474720"/>
+            <a:ext cx="4750308" cy="365760"/>
+          </a:xfrm>
+          <a:prstGeom prst="rect">
+            <a:avLst/>
+          </a:prstGeom>
+          <a:noFill/>
+          <a:ln/>
+        </p:spPr>
+        <p:txBody>
+          <a:bodyPr wrap="square" lIns="0" tIns="0" rIns="0" bIns="0" rtlCol="0" anchor="t"/>
+          <a:lstStyle/>
+          <a:p>
+            <a:pPr indent="0" marL="0">
+              <a:lnSpc>
+                <a:spcPts val="1600"/>
+              </a:lnSpc>
+              <a:buNone/>
+            </a:pPr>
+            <a:r>
+              <a:rPr lang="en-US" sz="1200" dirty="0">
+                <a:solidFill>
+                  <a:srgbClr val="E4EDE5"/>
+                </a:solidFill>
+                <a:latin typeface="Calibri" pitchFamily="34" charset="0"/>
+                <a:ea typeface="Calibri" pitchFamily="34" charset="-122"/>
+                <a:cs typeface="Calibri" pitchFamily="34" charset="-120"/>
+              </a:rPr>
+              <a:t>Genauer Termin folgt. Haltet euch die Abende im September frei - es lohnt sich.</a:t>
+            </a:r>
+            <a:endParaRPr lang="en-US" sz="1200" dirty="0"/>
+          </a:p>
+        </p:txBody>
+      </p:sp>
+      <p:sp>
+        <p:nvSpPr>
+          <p:cNvPr id="11" name="Shape 9"/>
+          <p:cNvSpPr/>
+          <p:nvPr/>
+        </p:nvSpPr>
+        <p:spPr>
+          <a:xfrm>
+            <a:off x="6249924" y="1847088"/>
+            <a:ext cx="5372100" cy="621792"/>
+          </a:xfrm>
+          <a:prstGeom prst="roundRect">
+            <a:avLst>
+              <a:gd name="adj" fmla="val 10294"/>
+            </a:avLst>
+          </a:prstGeom>
+          <a:solidFill>
+            <a:srgbClr val="F5F6F3"/>
+          </a:solidFill>
+          <a:ln/>
+        </p:spPr>
+      </p:sp>
+      <p:sp>
+        <p:nvSpPr>
+          <p:cNvPr id="12" name="Shape 10"/>
+          <p:cNvSpPr/>
+          <p:nvPr/>
+        </p:nvSpPr>
+        <p:spPr>
+          <a:xfrm>
+            <a:off x="6469380" y="1993392"/>
+            <a:ext cx="329184" cy="329184"/>
+          </a:xfrm>
+          <a:prstGeom prst="ellipse">
+            <a:avLst/>
+          </a:prstGeom>
+          <a:solidFill>
+            <a:srgbClr val="58B264"/>
+          </a:solidFill>
+          <a:ln/>
+        </p:spPr>
+      </p:sp>
+      <p:sp>
+        <p:nvSpPr>
+          <p:cNvPr id="13" name="Text 11"/>
+          <p:cNvSpPr/>
+          <p:nvPr/>
+        </p:nvSpPr>
+        <p:spPr>
+          <a:xfrm>
+            <a:off x="6469380" y="1993392"/>
+            <a:ext cx="329184" cy="329184"/>
+          </a:xfrm>
+          <a:prstGeom prst="rect">
+            <a:avLst/>
+          </a:prstGeom>
+          <a:noFill/>
+          <a:ln/>
+        </p:spPr>
+        <p:txBody>
+          <a:bodyPr wrap="square" lIns="0" tIns="0" rIns="0" bIns="0" rtlCol="0" anchor="ctr"/>
+          <a:lstStyle/>
+          <a:p>
+            <a:pPr algn="ctr" indent="0" marL="0">
+              <a:buNone/>
+            </a:pPr>
+            <a:r>
+              <a:rPr lang="en-US" sz="1200" b="1" dirty="0">
+                <a:solidFill>
+                  <a:srgbClr val="FFFFFF"/>
+                </a:solidFill>
+                <a:latin typeface="Calibri" pitchFamily="34" charset="0"/>
+                <a:ea typeface="Calibri" pitchFamily="34" charset="-122"/>
+                <a:cs typeface="Calibri" pitchFamily="34" charset="-120"/>
+              </a:rPr>
+              <a:t>1</a:t>
+            </a:r>
+            <a:endParaRPr lang="en-US" sz="1200" dirty="0"/>
+          </a:p>
+        </p:txBody>
+      </p:sp>
+      <p:sp>
+        <p:nvSpPr>
+          <p:cNvPr id="14" name="Text 12"/>
+          <p:cNvSpPr/>
+          <p:nvPr/>
+        </p:nvSpPr>
+        <p:spPr>
+          <a:xfrm>
+            <a:off x="6908292" y="1883664"/>
+            <a:ext cx="4494276" cy="274320"/>
+          </a:xfrm>
+          <a:prstGeom prst="rect">
+            <a:avLst/>
+          </a:prstGeom>
+          <a:noFill/>
+          <a:ln/>
+        </p:spPr>
+        <p:txBody>
+          <a:bodyPr wrap="square" lIns="0" tIns="0" rIns="0" bIns="0" rtlCol="0" anchor="ctr"/>
+          <a:lstStyle/>
+          <a:p>
+            <a:pPr indent="0" marL="0">
+              <a:buNone/>
+            </a:pPr>
+            <a:r>
+              <a:rPr lang="en-US" sz="1350" b="1" dirty="0">
+                <a:solidFill>
+                  <a:srgbClr val="1A1819"/>
+                </a:solidFill>
+                <a:latin typeface="Trebuchet MS" pitchFamily="34" charset="0"/>
+                <a:ea typeface="Trebuchet MS" pitchFamily="34" charset="-122"/>
+                <a:cs typeface="Trebuchet MS" pitchFamily="34" charset="-120"/>
+              </a:rPr>
+              <a:t>JobRad-Inspektion</a:t>
+            </a:r>
+            <a:endParaRPr lang="en-US" sz="1350" dirty="0"/>
+          </a:p>
+        </p:txBody>
+      </p:sp>
+      <p:sp>
+        <p:nvSpPr>
+          <p:cNvPr id="15" name="Text 13"/>
+          <p:cNvSpPr/>
+          <p:nvPr/>
+        </p:nvSpPr>
+        <p:spPr>
+          <a:xfrm>
+            <a:off x="6908292" y="2130552"/>
+            <a:ext cx="4512564" cy="310896"/>
+          </a:xfrm>
+          <a:prstGeom prst="rect">
+            <a:avLst/>
+          </a:prstGeom>
+          <a:noFill/>
+          <a:ln/>
+        </p:spPr>
+        <p:txBody>
+          <a:bodyPr wrap="square" lIns="0" tIns="0" rIns="0" bIns="0" rtlCol="0" anchor="ctr"/>
+          <a:lstStyle/>
+          <a:p>
+            <a:pPr indent="0" marL="0">
+              <a:buNone/>
+            </a:pPr>
+            <a:r>
+              <a:rPr lang="en-US" sz="1050" dirty="0">
+                <a:solidFill>
+                  <a:srgbClr val="5B685D"/>
+                </a:solidFill>
+                <a:latin typeface="Calibri" pitchFamily="34" charset="0"/>
+                <a:ea typeface="Calibri" pitchFamily="34" charset="-122"/>
+                <a:cs typeface="Calibri" pitchFamily="34" charset="-120"/>
+              </a:rPr>
+              <a:t>Rad durchchecken lassen - ist bereits bezahlt.</a:t>
+            </a:r>
+            <a:endParaRPr lang="en-US" sz="1050" dirty="0"/>
+          </a:p>
+        </p:txBody>
+      </p:sp>
+      <p:sp>
+        <p:nvSpPr>
+          <p:cNvPr id="16" name="Shape 14"/>
+          <p:cNvSpPr/>
+          <p:nvPr/>
+        </p:nvSpPr>
+        <p:spPr>
+          <a:xfrm>
+            <a:off x="6249924" y="2542032"/>
+            <a:ext cx="5372100" cy="621792"/>
+          </a:xfrm>
+          <a:prstGeom prst="roundRect">
+            <a:avLst>
+              <a:gd name="adj" fmla="val 10294"/>
+            </a:avLst>
+          </a:prstGeom>
+          <a:solidFill>
+            <a:srgbClr val="F5F6F3"/>
+          </a:solidFill>
+          <a:ln/>
+        </p:spPr>
+      </p:sp>
+      <p:sp>
+        <p:nvSpPr>
+          <p:cNvPr id="17" name="Shape 15"/>
+          <p:cNvSpPr/>
+          <p:nvPr/>
+        </p:nvSpPr>
+        <p:spPr>
+          <a:xfrm>
+            <a:off x="6469380" y="2688336"/>
+            <a:ext cx="329184" cy="329184"/>
+          </a:xfrm>
+          <a:prstGeom prst="ellipse">
+            <a:avLst/>
+          </a:prstGeom>
+          <a:solidFill>
+            <a:srgbClr val="58B264"/>
+          </a:solidFill>
+          <a:ln/>
+        </p:spPr>
+      </p:sp>
+      <p:sp>
+        <p:nvSpPr>
+          <p:cNvPr id="18" name="Text 16"/>
+          <p:cNvSpPr/>
+          <p:nvPr/>
+        </p:nvSpPr>
+        <p:spPr>
+          <a:xfrm>
+            <a:off x="6469380" y="2688336"/>
+            <a:ext cx="329184" cy="329184"/>
+          </a:xfrm>
+          <a:prstGeom prst="rect">
+            <a:avLst/>
+          </a:prstGeom>
+          <a:noFill/>
+          <a:ln/>
+        </p:spPr>
+        <p:txBody>
+          <a:bodyPr wrap="square" lIns="0" tIns="0" rIns="0" bIns="0" rtlCol="0" anchor="ctr"/>
+          <a:lstStyle/>
+          <a:p>
+            <a:pPr algn="ctr" indent="0" marL="0">
+              <a:buNone/>
+            </a:pPr>
+            <a:r>
+              <a:rPr lang="en-US" sz="1200" b="1" dirty="0">
+                <a:solidFill>
+                  <a:srgbClr val="FFFFFF"/>
+                </a:solidFill>
+                <a:latin typeface="Calibri" pitchFamily="34" charset="0"/>
+                <a:ea typeface="Calibri" pitchFamily="34" charset="-122"/>
+                <a:cs typeface="Calibri" pitchFamily="34" charset="-120"/>
+              </a:rPr>
+              <a:t>2</a:t>
+            </a:r>
+            <a:endParaRPr lang="en-US" sz="1200" dirty="0"/>
+          </a:p>
+        </p:txBody>
+      </p:sp>
+      <p:sp>
+        <p:nvSpPr>
+          <p:cNvPr id="19" name="Text 17"/>
+          <p:cNvSpPr/>
+          <p:nvPr/>
+        </p:nvSpPr>
+        <p:spPr>
+          <a:xfrm>
+            <a:off x="6908292" y="2578608"/>
+            <a:ext cx="4494276" cy="274320"/>
+          </a:xfrm>
+          <a:prstGeom prst="rect">
+            <a:avLst/>
+          </a:prstGeom>
+          <a:noFill/>
+          <a:ln/>
+        </p:spPr>
+        <p:txBody>
+          <a:bodyPr wrap="square" lIns="0" tIns="0" rIns="0" bIns="0" rtlCol="0" anchor="ctr"/>
+          <a:lstStyle/>
+          <a:p>
+            <a:pPr indent="0" marL="0">
+              <a:buNone/>
+            </a:pPr>
+            <a:r>
+              <a:rPr lang="en-US" sz="1350" b="1" dirty="0">
+                <a:solidFill>
+                  <a:srgbClr val="1A1819"/>
+                </a:solidFill>
+                <a:latin typeface="Trebuchet MS" pitchFamily="34" charset="0"/>
+                <a:ea typeface="Trebuchet MS" pitchFamily="34" charset="-122"/>
+                <a:cs typeface="Trebuchet MS" pitchFamily="34" charset="-120"/>
+              </a:rPr>
+              <a:t>Volksbank-Event</a:t>
+            </a:r>
+            <a:endParaRPr lang="en-US" sz="1350" dirty="0"/>
+          </a:p>
+        </p:txBody>
+      </p:sp>
+      <p:sp>
+        <p:nvSpPr>
+          <p:cNvPr id="20" name="Text 18"/>
+          <p:cNvSpPr/>
+          <p:nvPr/>
+        </p:nvSpPr>
+        <p:spPr>
+          <a:xfrm>
+            <a:off x="6908292" y="2825496"/>
+            <a:ext cx="4512564" cy="310896"/>
+          </a:xfrm>
+          <a:prstGeom prst="rect">
+            <a:avLst/>
+          </a:prstGeom>
+          <a:noFill/>
+          <a:ln/>
+        </p:spPr>
+        <p:txBody>
+          <a:bodyPr wrap="square" lIns="0" tIns="0" rIns="0" bIns="0" rtlCol="0" anchor="ctr"/>
+          <a:lstStyle/>
+          <a:p>
+            <a:pPr indent="0" marL="0">
+              <a:buNone/>
+            </a:pPr>
+            <a:r>
+              <a:rPr lang="en-US" sz="1050" dirty="0">
+                <a:solidFill>
+                  <a:srgbClr val="5B685D"/>
+                </a:solidFill>
+                <a:latin typeface="Calibri" pitchFamily="34" charset="0"/>
+                <a:ea typeface="Calibri" pitchFamily="34" charset="-122"/>
+                <a:cs typeface="Calibri" pitchFamily="34" charset="-120"/>
+              </a:rPr>
+              <a:t>Zusagen sind raus. Wer noch mit möchte, kurz melden.</a:t>
+            </a:r>
+            <a:endParaRPr lang="en-US" sz="1050" dirty="0"/>
+          </a:p>
+        </p:txBody>
+      </p:sp>
+      <p:sp>
+        <p:nvSpPr>
+          <p:cNvPr id="21" name="Shape 19"/>
+          <p:cNvSpPr/>
+          <p:nvPr/>
+        </p:nvSpPr>
+        <p:spPr>
+          <a:xfrm>
+            <a:off x="6249924" y="3236976"/>
+            <a:ext cx="5372100" cy="621792"/>
+          </a:xfrm>
+          <a:prstGeom prst="roundRect">
+            <a:avLst>
+              <a:gd name="adj" fmla="val 10294"/>
+            </a:avLst>
+          </a:prstGeom>
+          <a:solidFill>
+            <a:srgbClr val="F5F6F3"/>
+          </a:solidFill>
+          <a:ln/>
+        </p:spPr>
+      </p:sp>
+      <p:sp>
+        <p:nvSpPr>
+          <p:cNvPr id="22" name="Shape 20"/>
+          <p:cNvSpPr/>
+          <p:nvPr/>
+        </p:nvSpPr>
+        <p:spPr>
+          <a:xfrm>
+            <a:off x="6469380" y="3383280"/>
+            <a:ext cx="329184" cy="329184"/>
+          </a:xfrm>
+          <a:prstGeom prst="ellipse">
+            <a:avLst/>
+          </a:prstGeom>
+          <a:solidFill>
+            <a:srgbClr val="58B264"/>
+          </a:solidFill>
+          <a:ln/>
+        </p:spPr>
+      </p:sp>
+      <p:sp>
+        <p:nvSpPr>
+          <p:cNvPr id="23" name="Text 21"/>
+          <p:cNvSpPr/>
+          <p:nvPr/>
+        </p:nvSpPr>
+        <p:spPr>
+          <a:xfrm>
+            <a:off x="6469380" y="3383280"/>
+            <a:ext cx="329184" cy="329184"/>
+          </a:xfrm>
+          <a:prstGeom prst="rect">
+            <a:avLst/>
+          </a:prstGeom>
+          <a:noFill/>
+          <a:ln/>
+        </p:spPr>
+        <p:txBody>
+          <a:bodyPr wrap="square" lIns="0" tIns="0" rIns="0" bIns="0" rtlCol="0" anchor="ctr"/>
+          <a:lstStyle/>
+          <a:p>
+            <a:pPr algn="ctr" indent="0" marL="0">
+              <a:buNone/>
+            </a:pPr>
+            <a:r>
+              <a:rPr lang="en-US" sz="1200" b="1" dirty="0">
+                <a:solidFill>
+                  <a:srgbClr val="FFFFFF"/>
+                </a:solidFill>
+                <a:latin typeface="Calibri" pitchFamily="34" charset="0"/>
+                <a:ea typeface="Calibri" pitchFamily="34" charset="-122"/>
+                <a:cs typeface="Calibri" pitchFamily="34" charset="-120"/>
+              </a:rPr>
+              <a:t>3</a:t>
+            </a:r>
+            <a:endParaRPr lang="en-US" sz="1200" dirty="0"/>
+          </a:p>
+        </p:txBody>
+      </p:sp>
+      <p:sp>
+        <p:nvSpPr>
+          <p:cNvPr id="24" name="Text 22"/>
+          <p:cNvSpPr/>
+          <p:nvPr/>
+        </p:nvSpPr>
+        <p:spPr>
+          <a:xfrm>
+            <a:off x="6908292" y="3273552"/>
+            <a:ext cx="4494276" cy="274320"/>
+          </a:xfrm>
+          <a:prstGeom prst="rect">
+            <a:avLst/>
+          </a:prstGeom>
+          <a:noFill/>
+          <a:ln/>
+        </p:spPr>
+        <p:txBody>
+          <a:bodyPr wrap="square" lIns="0" tIns="0" rIns="0" bIns="0" rtlCol="0" anchor="ctr"/>
+          <a:lstStyle/>
+          <a:p>
+            <a:pPr indent="0" marL="0">
+              <a:buNone/>
+            </a:pPr>
+            <a:r>
+              <a:rPr lang="en-US" sz="1350" b="1" dirty="0">
+                <a:solidFill>
+                  <a:srgbClr val="1A1819"/>
+                </a:solidFill>
+                <a:latin typeface="Trebuchet MS" pitchFamily="34" charset="0"/>
+                <a:ea typeface="Trebuchet MS" pitchFamily="34" charset="-122"/>
+                <a:cs typeface="Trebuchet MS" pitchFamily="34" charset="-120"/>
+              </a:rPr>
+              <a:t>SC Paderborn</a:t>
+            </a:r>
+            <a:endParaRPr lang="en-US" sz="1350" dirty="0"/>
+          </a:p>
+        </p:txBody>
+      </p:sp>
+      <p:sp>
+        <p:nvSpPr>
+          <p:cNvPr id="25" name="Text 23"/>
+          <p:cNvSpPr/>
+          <p:nvPr/>
+        </p:nvSpPr>
+        <p:spPr>
+          <a:xfrm>
+            <a:off x="6908292" y="3520440"/>
+            <a:ext cx="4512564" cy="310896"/>
+          </a:xfrm>
+          <a:prstGeom prst="rect">
+            <a:avLst/>
+          </a:prstGeom>
+          <a:noFill/>
+          <a:ln/>
+        </p:spPr>
+        <p:txBody>
+          <a:bodyPr wrap="square" lIns="0" tIns="0" rIns="0" bIns="0" rtlCol="0" anchor="ctr"/>
+          <a:lstStyle/>
+          <a:p>
+            <a:pPr indent="0" marL="0">
+              <a:buNone/>
+            </a:pPr>
+            <a:r>
+              <a:rPr lang="en-US" sz="1050" dirty="0">
+                <a:solidFill>
+                  <a:srgbClr val="5B685D"/>
+                </a:solidFill>
+                <a:latin typeface="Calibri" pitchFamily="34" charset="0"/>
+                <a:ea typeface="Calibri" pitchFamily="34" charset="-122"/>
+                <a:cs typeface="Calibri" pitchFamily="34" charset="-120"/>
+              </a:rPr>
+              <a:t>Auswärtsspiel Mainz, VIP-Ticket 270 €. Interesse an Annika.</a:t>
+            </a:r>
+            <a:endParaRPr lang="en-US" sz="1050" dirty="0"/>
+          </a:p>
+        </p:txBody>
+      </p:sp>
+      <p:sp>
+        <p:nvSpPr>
+          <p:cNvPr id="26" name="Shape 24"/>
+          <p:cNvSpPr/>
+          <p:nvPr/>
+        </p:nvSpPr>
+        <p:spPr>
+          <a:xfrm>
+            <a:off x="6249924" y="3931920"/>
+            <a:ext cx="5372100" cy="621792"/>
+          </a:xfrm>
+          <a:prstGeom prst="roundRect">
+            <a:avLst>
+              <a:gd name="adj" fmla="val 10294"/>
+            </a:avLst>
+          </a:prstGeom>
+          <a:solidFill>
+            <a:srgbClr val="EDF5EE"/>
+          </a:solidFill>
+          <a:ln/>
+        </p:spPr>
+      </p:sp>
+      <p:sp>
+        <p:nvSpPr>
+          <p:cNvPr id="27" name="Shape 25"/>
+          <p:cNvSpPr/>
+          <p:nvPr/>
+        </p:nvSpPr>
+        <p:spPr>
+          <a:xfrm>
+            <a:off x="6469380" y="4078224"/>
+            <a:ext cx="329184" cy="329184"/>
+          </a:xfrm>
+          <a:prstGeom prst="ellipse">
+            <a:avLst/>
+          </a:prstGeom>
+          <a:solidFill>
+            <a:srgbClr val="2E7D3A"/>
+          </a:solidFill>
+          <a:ln/>
+        </p:spPr>
+      </p:sp>
+      <p:sp>
+        <p:nvSpPr>
+          <p:cNvPr id="28" name="Text 26"/>
+          <p:cNvSpPr/>
+          <p:nvPr/>
+        </p:nvSpPr>
+        <p:spPr>
+          <a:xfrm>
+            <a:off x="6469380" y="4078224"/>
+            <a:ext cx="329184" cy="329184"/>
+          </a:xfrm>
+          <a:prstGeom prst="rect">
+            <a:avLst/>
+          </a:prstGeom>
+          <a:noFill/>
+          <a:ln/>
+        </p:spPr>
+        <p:txBody>
+          <a:bodyPr wrap="square" lIns="0" tIns="0" rIns="0" bIns="0" rtlCol="0" anchor="ctr"/>
+          <a:lstStyle/>
+          <a:p>
+            <a:pPr algn="ctr" indent="0" marL="0">
+              <a:buNone/>
+            </a:pPr>
+            <a:r>
+              <a:rPr lang="en-US" sz="1200" b="1" dirty="0">
+                <a:solidFill>
+                  <a:srgbClr val="FFFFFF"/>
+                </a:solidFill>
+                <a:latin typeface="Calibri" pitchFamily="34" charset="0"/>
+                <a:ea typeface="Calibri" pitchFamily="34" charset="-122"/>
+                <a:cs typeface="Calibri" pitchFamily="34" charset="-120"/>
+              </a:rPr>
+              <a:t>4</a:t>
+            </a:r>
+            <a:endParaRPr lang="en-US" sz="1200" dirty="0"/>
+          </a:p>
+        </p:txBody>
+      </p:sp>
+      <p:sp>
+        <p:nvSpPr>
+          <p:cNvPr id="29" name="Text 27"/>
+          <p:cNvSpPr/>
+          <p:nvPr/>
+        </p:nvSpPr>
+        <p:spPr>
+          <a:xfrm>
+            <a:off x="6908292" y="3968496"/>
+            <a:ext cx="4494276" cy="274320"/>
+          </a:xfrm>
+          <a:prstGeom prst="rect">
+            <a:avLst/>
+          </a:prstGeom>
+          <a:noFill/>
+          <a:ln/>
+        </p:spPr>
+        <p:txBody>
+          <a:bodyPr wrap="square" lIns="0" tIns="0" rIns="0" bIns="0" rtlCol="0" anchor="ctr"/>
+          <a:lstStyle/>
+          <a:p>
+            <a:pPr indent="0" marL="0">
+              <a:buNone/>
+            </a:pPr>
+            <a:r>
+              <a:rPr lang="en-US" sz="1350" b="1" dirty="0">
+                <a:solidFill>
+                  <a:srgbClr val="1A1819"/>
+                </a:solidFill>
+                <a:latin typeface="Trebuchet MS" pitchFamily="34" charset="0"/>
+                <a:ea typeface="Trebuchet MS" pitchFamily="34" charset="-122"/>
+                <a:cs typeface="Trebuchet MS" pitchFamily="34" charset="-120"/>
+              </a:rPr>
+              <a:t>Neuer Opel Grandland</a:t>
+            </a:r>
+            <a:endParaRPr lang="en-US" sz="1350" dirty="0"/>
+          </a:p>
+        </p:txBody>
+      </p:sp>
+      <p:sp>
+        <p:nvSpPr>
+          <p:cNvPr id="30" name="Text 28"/>
+          <p:cNvSpPr/>
+          <p:nvPr/>
+        </p:nvSpPr>
+        <p:spPr>
+          <a:xfrm>
+            <a:off x="6908292" y="4224528"/>
+            <a:ext cx="4512564" cy="274320"/>
+          </a:xfrm>
+          <a:prstGeom prst="rect">
+            <a:avLst/>
+          </a:prstGeom>
+          <a:noFill/>
+          <a:ln/>
+        </p:spPr>
+        <p:txBody>
+          <a:bodyPr wrap="square" lIns="0" tIns="0" rIns="0" bIns="0" rtlCol="0" anchor="ctr"/>
+          <a:lstStyle/>
+          <a:p>
+            <a:pPr indent="0" marL="0">
+              <a:buNone/>
+            </a:pPr>
+            <a:r>
+              <a:rPr lang="en-US" sz="1050" dirty="0">
+                <a:solidFill>
+                  <a:srgbClr val="5B685D"/>
+                </a:solidFill>
+                <a:latin typeface="Calibri" pitchFamily="34" charset="0"/>
+                <a:ea typeface="Calibri" pitchFamily="34" charset="-122"/>
+                <a:cs typeface="Calibri" pitchFamily="34" charset="-120"/>
+              </a:rPr>
+              <a:t>Ist geliefert. Die Fahrzeugpapiere liegen bei Melissa.</a:t>
+            </a:r>
+            <a:endParaRPr lang="en-US" sz="1050" dirty="0"/>
+          </a:p>
+        </p:txBody>
+      </p:sp>
+      <p:sp>
+        <p:nvSpPr>
+          <p:cNvPr id="31" name="Shape 29"/>
+          <p:cNvSpPr/>
+          <p:nvPr/>
+        </p:nvSpPr>
+        <p:spPr>
+          <a:xfrm>
+            <a:off x="566928" y="4224528"/>
+            <a:ext cx="5372100" cy="1481328"/>
+          </a:xfrm>
+          <a:prstGeom prst="roundRect">
+            <a:avLst>
+              <a:gd name="adj" fmla="val 5556"/>
+            </a:avLst>
+          </a:prstGeom>
+          <a:solidFill>
+            <a:srgbClr val="F5F6F3"/>
+          </a:solidFill>
+          <a:ln/>
+          <a:effectLst>
+            <a:outerShdw sx="100000" sy="100000" kx="0" ky="0" algn="bl" rotWithShape="0" blurRad="127000" dist="25400" dir="5400000">
+              <a:srgbClr val="000000">
+                <a:alpha val="7000"/>
+              </a:srgbClr>
+            </a:outerShdw>
+          </a:effectLst>
+        </p:spPr>
+      </p:sp>
+      <p:sp>
+        <p:nvSpPr>
+          <p:cNvPr id="32" name="Text 30"/>
+          <p:cNvSpPr/>
+          <p:nvPr/>
+        </p:nvSpPr>
+        <p:spPr>
+          <a:xfrm>
+            <a:off x="877824" y="4407408"/>
+            <a:ext cx="4750308" cy="310896"/>
+          </a:xfrm>
+          <a:prstGeom prst="rect">
+            <a:avLst/>
+          </a:prstGeom>
+          <a:noFill/>
+          <a:ln/>
+        </p:spPr>
+        <p:txBody>
+          <a:bodyPr wrap="square" lIns="0" tIns="0" rIns="0" bIns="0" rtlCol="0" anchor="ctr"/>
+          <a:lstStyle/>
+          <a:p>
+            <a:pPr indent="0" marL="0">
+              <a:buNone/>
+            </a:pPr>
+            <a:r>
+              <a:rPr lang="en-US" sz="1600" b="1" dirty="0">
+                <a:solidFill>
+                  <a:srgbClr val="2E7D3A"/>
+                </a:solidFill>
+                <a:latin typeface="Trebuchet MS" pitchFamily="34" charset="0"/>
+                <a:ea typeface="Trebuchet MS" pitchFamily="34" charset="-122"/>
+                <a:cs typeface="Trebuchet MS" pitchFamily="34" charset="-120"/>
+              </a:rPr>
+              <a:t>Fragen, Anliegen, Ideen?</a:t>
+            </a:r>
+            <a:endParaRPr lang="en-US" sz="1600" dirty="0"/>
+          </a:p>
+        </p:txBody>
+      </p:sp>
+      <p:sp>
+        <p:nvSpPr>
+          <p:cNvPr id="33" name="Text 31"/>
+          <p:cNvSpPr/>
+          <p:nvPr/>
+        </p:nvSpPr>
+        <p:spPr>
+          <a:xfrm>
+            <a:off x="896112" y="4773168"/>
+            <a:ext cx="4713732" cy="786384"/>
+          </a:xfrm>
+          <a:prstGeom prst="rect">
+            <a:avLst/>
+          </a:prstGeom>
+          <a:noFill/>
+          <a:ln/>
+        </p:spPr>
+        <p:txBody>
+          <a:bodyPr wrap="square" lIns="0" tIns="0" rIns="0" bIns="0" rtlCol="0" anchor="t"/>
+          <a:lstStyle/>
+          <a:p>
+            <a:pPr indent="0" marL="0">
+              <a:lnSpc>
+                <a:spcPts val="1700"/>
+              </a:lnSpc>
+              <a:buNone/>
+            </a:pPr>
+            <a:r>
+              <a:rPr lang="en-US" sz="1250" dirty="0">
+                <a:solidFill>
+                  <a:srgbClr val="1A1819"/>
+                </a:solidFill>
+                <a:latin typeface="Calibri" pitchFamily="34" charset="0"/>
+                <a:ea typeface="Calibri" pitchFamily="34" charset="-122"/>
+                <a:cs typeface="Calibri" pitchFamily="34" charset="-120"/>
+              </a:rPr>
+              <a:t>Meine Tür steht offen, und über den Buchungskalender könnt ihr euch jederzeit selbst einen Termin bei mir legen. Kein Anlass ist dafür zu klein.</a:t>
+            </a:r>
+            <a:endParaRPr lang="en-US" sz="1250" dirty="0"/>
+          </a:p>
+        </p:txBody>
+      </p:sp>
+      <p:sp>
+        <p:nvSpPr>
+          <p:cNvPr id="35" name="Text 32"/>
+          <p:cNvSpPr/>
+          <p:nvPr/>
+        </p:nvSpPr>
+        <p:spPr>
+          <a:xfrm>
+            <a:off x="566928" y="6437376"/>
+            <a:ext cx="11055096" cy="237744"/>
+          </a:xfrm>
+          <a:prstGeom prst="rect">
+            <a:avLst/>
+          </a:prstGeom>
+          <a:noFill/>
+          <a:ln/>
+        </p:spPr>
+        <p:txBody>
+          <a:bodyPr wrap="square" lIns="0" tIns="0" rIns="0" bIns="0" rtlCol="0" anchor="ctr"/>
+          <a:lstStyle/>
+          <a:p>
+            <a:pPr indent="0" marL="0">
+              <a:buNone/>
+            </a:pPr>
+            <a:r>
+              <a:rPr lang="en-US" sz="900" dirty="0">
+                <a:solidFill>
+                  <a:srgbClr val="5B685D"/>
+                </a:solidFill>
+                <a:latin typeface="Calibri" pitchFamily="34" charset="0"/>
+                <a:ea typeface="Calibri" pitchFamily="34" charset="-122"/>
+                <a:cs typeface="Calibri" pitchFamily="34" charset="-120"/>
+              </a:rPr>
+              <a:t>Stand 06.08.2026</a:t>
+            </a:r>
+            <a:endParaRPr lang="en-US" sz="900" dirty="0"/>
+          </a:p>
+        </p:txBody>
+      </p:sp>
+    </p:spTree>
+  </p:cSld>
+  <p:clrMapOvr>
+    <a:masterClrMapping/>
+  </p:clrMapOvr>
+</p:sld>
+</file>
+
+<file path=ppt/slides/slide21.xml><?xml version="1.0" encoding="utf-8"?>
+<p:sld xmlns:a="http://schemas.openxmlformats.org/drawingml/2006/main" xmlns:r="http://schemas.openxmlformats.org/officeDocument/2006/relationships" xmlns:p="http://schemas.openxmlformats.org/presentationml/2006/main">
+  <p:cSld name="Slide 21">
     <p:bg>
       <p:bgPr>
         <a:solidFill>
@@ -11692,8 +12494,8 @@
         </p:nvSpPr>
         <p:spPr>
           <a:xfrm>
-            <a:off x="566928" y="1609344"/>
-            <a:ext cx="365760" cy="365760"/>
+            <a:off x="566928" y="1517904"/>
+            <a:ext cx="347472" cy="347472"/>
           </a:xfrm>
           <a:prstGeom prst="ellipse">
             <a:avLst/>
@@ -11712,8 +12514,8 @@
         </p:nvSpPr>
         <p:spPr>
           <a:xfrm>
-            <a:off x="566928" y="1609344"/>
-            <a:ext cx="365760" cy="365760"/>
+            <a:off x="566928" y="1517904"/>
+            <a:ext cx="347472" cy="347472"/>
           </a:xfrm>
           <a:prstGeom prst="rect">
             <a:avLst/>
@@ -11729,7 +12531,7 @@
               <a:buNone/>
             </a:pPr>
             <a:r>
-              <a:rPr lang="en-US" sz="1300" b="1" dirty="0">
+              <a:rPr lang="en-US" sz="1250" b="1" dirty="0">
                 <a:solidFill>
                   <a:srgbClr val="FFFFFF"/>
                 </a:solidFill>
@@ -11739,7 +12541,7 @@
               </a:rPr>
               <a:t>1</a:t>
             </a:r>
-            <a:endParaRPr lang="en-US" sz="1300" dirty="0"/>
+            <a:endParaRPr lang="en-US" sz="1250" dirty="0"/>
           </a:p>
         </p:txBody>
       </p:sp>
@@ -11751,24 +12553,24 @@
         </p:nvSpPr>
         <p:spPr>
           <a:xfrm>
-            <a:off x="1133856" y="1554480"/>
-            <a:ext cx="8778240" cy="475488"/>
-          </a:xfrm>
-          <a:prstGeom prst="rect">
-            <a:avLst/>
-          </a:prstGeom>
-          <a:noFill/>
-          <a:ln/>
-        </p:spPr>
-        <p:txBody>
-          <a:bodyPr wrap="square" lIns="0" tIns="0" rIns="0" bIns="0" rtlCol="0" anchor="ctr"/>
-          <a:lstStyle/>
-          <a:p>
-            <a:pPr indent="0" marL="0">
-              <a:buNone/>
-            </a:pPr>
-            <a:r>
-              <a:rPr lang="en-US" sz="1400" dirty="0">
+            <a:off x="1115568" y="1481328"/>
+            <a:ext cx="8869680" cy="438912"/>
+          </a:xfrm>
+          <a:prstGeom prst="rect">
+            <a:avLst/>
+          </a:prstGeom>
+          <a:noFill/>
+          <a:ln/>
+        </p:spPr>
+        <p:txBody>
+          <a:bodyPr wrap="square" lIns="0" tIns="0" rIns="0" bIns="0" rtlCol="0" anchor="ctr"/>
+          <a:lstStyle/>
+          <a:p>
+            <a:pPr indent="0" marL="0">
+              <a:buNone/>
+            </a:pPr>
+            <a:r>
+              <a:rPr lang="en-US" sz="1350" dirty="0">
                 <a:solidFill>
                   <a:srgbClr val="FFFFFF"/>
                 </a:solidFill>
@@ -11778,7 +12580,7 @@
               </a:rPr>
               <a:t>Das GModG gilt. Die 65-%-Pflicht ist Geschichte - keine alten Konzepte mehr im Kundengespräch.</a:t>
             </a:r>
-            <a:endParaRPr lang="en-US" sz="1400" dirty="0"/>
+            <a:endParaRPr lang="en-US" sz="1350" dirty="0"/>
           </a:p>
         </p:txBody>
       </p:sp>
@@ -11790,8 +12592,8 @@
         </p:nvSpPr>
         <p:spPr>
           <a:xfrm>
-            <a:off x="566928" y="2212848"/>
-            <a:ext cx="365760" cy="365760"/>
+            <a:off x="566928" y="2066544"/>
+            <a:ext cx="347472" cy="347472"/>
           </a:xfrm>
           <a:prstGeom prst="ellipse">
             <a:avLst/>
@@ -11810,8 +12612,8 @@
         </p:nvSpPr>
         <p:spPr>
           <a:xfrm>
-            <a:off x="566928" y="2212848"/>
-            <a:ext cx="365760" cy="365760"/>
+            <a:off x="566928" y="2066544"/>
+            <a:ext cx="347472" cy="347472"/>
           </a:xfrm>
           <a:prstGeom prst="rect">
             <a:avLst/>
@@ -11827,7 +12629,7 @@
               <a:buNone/>
             </a:pPr>
             <a:r>
-              <a:rPr lang="en-US" sz="1300" b="1" dirty="0">
+              <a:rPr lang="en-US" sz="1250" b="1" dirty="0">
                 <a:solidFill>
                   <a:srgbClr val="FFFFFF"/>
                 </a:solidFill>
@@ -11837,7 +12639,7 @@
               </a:rPr>
               <a:t>2</a:t>
             </a:r>
-            <a:endParaRPr lang="en-US" sz="1300" dirty="0"/>
+            <a:endParaRPr lang="en-US" sz="1250" dirty="0"/>
           </a:p>
         </p:txBody>
       </p:sp>
@@ -11849,24 +12651,24 @@
         </p:nvSpPr>
         <p:spPr>
           <a:xfrm>
-            <a:off x="1133856" y="2157984"/>
-            <a:ext cx="8778240" cy="475488"/>
-          </a:xfrm>
-          <a:prstGeom prst="rect">
-            <a:avLst/>
-          </a:prstGeom>
-          <a:noFill/>
-          <a:ln/>
-        </p:spPr>
-        <p:txBody>
-          <a:bodyPr wrap="square" lIns="0" tIns="0" rIns="0" bIns="0" rtlCol="0" anchor="ctr"/>
-          <a:lstStyle/>
-          <a:p>
-            <a:pPr indent="0" marL="0">
-              <a:buNone/>
-            </a:pPr>
-            <a:r>
-              <a:rPr lang="en-US" sz="1400" dirty="0">
+            <a:off x="1115568" y="2029968"/>
+            <a:ext cx="8869680" cy="438912"/>
+          </a:xfrm>
+          <a:prstGeom prst="rect">
+            <a:avLst/>
+          </a:prstGeom>
+          <a:noFill/>
+          <a:ln/>
+        </p:spPr>
+        <p:txBody>
+          <a:bodyPr wrap="square" lIns="0" tIns="0" rIns="0" bIns="0" rtlCol="0" anchor="ctr"/>
+          <a:lstStyle/>
+          <a:p>
+            <a:pPr indent="0" marL="0">
+              <a:buNone/>
+            </a:pPr>
+            <a:r>
+              <a:rPr lang="en-US" sz="1350" dirty="0">
                 <a:solidFill>
                   <a:srgbClr val="FFFFFF"/>
                 </a:solidFill>
@@ -11876,7 +12678,7 @@
               </a:rPr>
               <a:t>Ab Stufe 2 rund um den 01.01.2027 rechnen wir neu. Alte und neue Kennwerte sind nicht vergleichbar.</a:t>
             </a:r>
-            <a:endParaRPr lang="en-US" sz="1400" dirty="0"/>
+            <a:endParaRPr lang="en-US" sz="1350" dirty="0"/>
           </a:p>
         </p:txBody>
       </p:sp>
@@ -11888,8 +12690,8 @@
         </p:nvSpPr>
         <p:spPr>
           <a:xfrm>
-            <a:off x="566928" y="2816352"/>
-            <a:ext cx="365760" cy="365760"/>
+            <a:off x="566928" y="2615184"/>
+            <a:ext cx="347472" cy="347472"/>
           </a:xfrm>
           <a:prstGeom prst="ellipse">
             <a:avLst/>
@@ -11908,8 +12710,8 @@
         </p:nvSpPr>
         <p:spPr>
           <a:xfrm>
-            <a:off x="566928" y="2816352"/>
-            <a:ext cx="365760" cy="365760"/>
+            <a:off x="566928" y="2615184"/>
+            <a:ext cx="347472" cy="347472"/>
           </a:xfrm>
           <a:prstGeom prst="rect">
             <a:avLst/>
@@ -11925,7 +12727,7 @@
               <a:buNone/>
             </a:pPr>
             <a:r>
-              <a:rPr lang="en-US" sz="1300" b="1" dirty="0">
+              <a:rPr lang="en-US" sz="1250" b="1" dirty="0">
                 <a:solidFill>
                   <a:srgbClr val="FFFFFF"/>
                 </a:solidFill>
@@ -11935,7 +12737,7 @@
               </a:rPr>
               <a:t>3</a:t>
             </a:r>
-            <a:endParaRPr lang="en-US" sz="1300" dirty="0"/>
+            <a:endParaRPr lang="en-US" sz="1250" dirty="0"/>
           </a:p>
         </p:txBody>
       </p:sp>
@@ -11947,24 +12749,24 @@
         </p:nvSpPr>
         <p:spPr>
           <a:xfrm>
-            <a:off x="1133856" y="2761488"/>
-            <a:ext cx="8778240" cy="475488"/>
-          </a:xfrm>
-          <a:prstGeom prst="rect">
-            <a:avLst/>
-          </a:prstGeom>
-          <a:noFill/>
-          <a:ln/>
-        </p:spPr>
-        <p:txBody>
-          <a:bodyPr wrap="square" lIns="0" tIns="0" rIns="0" bIns="0" rtlCol="0" anchor="ctr"/>
-          <a:lstStyle/>
-          <a:p>
-            <a:pPr indent="0" marL="0">
-              <a:buNone/>
-            </a:pPr>
-            <a:r>
-              <a:rPr lang="en-US" sz="1400" dirty="0">
+            <a:off x="1115568" y="2578608"/>
+            <a:ext cx="8869680" cy="438912"/>
+          </a:xfrm>
+          <a:prstGeom prst="rect">
+            <a:avLst/>
+          </a:prstGeom>
+          <a:noFill/>
+          <a:ln/>
+        </p:spPr>
+        <p:txBody>
+          <a:bodyPr wrap="square" lIns="0" tIns="0" rIns="0" bIns="0" rtlCol="0" anchor="ctr"/>
+          <a:lstStyle/>
+          <a:p>
+            <a:pPr indent="0" marL="0">
+              <a:buNone/>
+            </a:pPr>
+            <a:r>
+              <a:rPr lang="en-US" sz="1350" dirty="0">
                 <a:solidFill>
                   <a:srgbClr val="FFFFFF"/>
                 </a:solidFill>
@@ -11974,7 +12776,7 @@
               </a:rPr>
               <a:t>Laden im Mehrparteienhaus: bis 2.000 € je Stellplatz - aber nur noch bis zum 10.11.2026.</a:t>
             </a:r>
-            <a:endParaRPr lang="en-US" sz="1400" dirty="0"/>
+            <a:endParaRPr lang="en-US" sz="1350" dirty="0"/>
           </a:p>
         </p:txBody>
       </p:sp>
@@ -11986,8 +12788,8 @@
         </p:nvSpPr>
         <p:spPr>
           <a:xfrm>
-            <a:off x="566928" y="3419856"/>
-            <a:ext cx="365760" cy="365760"/>
+            <a:off x="566928" y="3163824"/>
+            <a:ext cx="347472" cy="347472"/>
           </a:xfrm>
           <a:prstGeom prst="ellipse">
             <a:avLst/>
@@ -12006,8 +12808,8 @@
         </p:nvSpPr>
         <p:spPr>
           <a:xfrm>
-            <a:off x="566928" y="3419856"/>
-            <a:ext cx="365760" cy="365760"/>
+            <a:off x="566928" y="3163824"/>
+            <a:ext cx="347472" cy="347472"/>
           </a:xfrm>
           <a:prstGeom prst="rect">
             <a:avLst/>
@@ -12023,7 +12825,7 @@
               <a:buNone/>
             </a:pPr>
             <a:r>
-              <a:rPr lang="en-US" sz="1300" b="1" dirty="0">
+              <a:rPr lang="en-US" sz="1250" b="1" dirty="0">
                 <a:solidFill>
                   <a:srgbClr val="FFFFFF"/>
                 </a:solidFill>
@@ -12033,7 +12835,7 @@
               </a:rPr>
               <a:t>4</a:t>
             </a:r>
-            <a:endParaRPr lang="en-US" sz="1300" dirty="0"/>
+            <a:endParaRPr lang="en-US" sz="1250" dirty="0"/>
           </a:p>
         </p:txBody>
       </p:sp>
@@ -12045,24 +12847,24 @@
         </p:nvSpPr>
         <p:spPr>
           <a:xfrm>
-            <a:off x="1133856" y="3364992"/>
-            <a:ext cx="8778240" cy="475488"/>
-          </a:xfrm>
-          <a:prstGeom prst="rect">
-            <a:avLst/>
-          </a:prstGeom>
-          <a:noFill/>
-          <a:ln/>
-        </p:spPr>
-        <p:txBody>
-          <a:bodyPr wrap="square" lIns="0" tIns="0" rIns="0" bIns="0" rtlCol="0" anchor="ctr"/>
-          <a:lstStyle/>
-          <a:p>
-            <a:pPr indent="0" marL="0">
-              <a:buNone/>
-            </a:pPr>
-            <a:r>
-              <a:rPr lang="en-US" sz="1400" dirty="0">
+            <a:off x="1115568" y="3127248"/>
+            <a:ext cx="8869680" cy="438912"/>
+          </a:xfrm>
+          <a:prstGeom prst="rect">
+            <a:avLst/>
+          </a:prstGeom>
+          <a:noFill/>
+          <a:ln/>
+        </p:spPr>
+        <p:txBody>
+          <a:bodyPr wrap="square" lIns="0" tIns="0" rIns="0" bIns="0" rtlCol="0" anchor="ctr"/>
+          <a:lstStyle/>
+          <a:p>
+            <a:pPr indent="0" marL="0">
+              <a:buNone/>
+            </a:pPr>
+            <a:r>
+              <a:rPr lang="en-US" sz="1350" dirty="0">
                 <a:solidFill>
                   <a:srgbClr val="FFFFFF"/>
                 </a:solidFill>
@@ -12072,7 +12874,7 @@
               </a:rPr>
               <a:t>Puffer in die BzA. Wir haben keinen Nachteil, wenn mehr drinsteht.</a:t>
             </a:r>
-            <a:endParaRPr lang="en-US" sz="1400" dirty="0"/>
+            <a:endParaRPr lang="en-US" sz="1350" dirty="0"/>
           </a:p>
         </p:txBody>
       </p:sp>
@@ -12084,8 +12886,8 @@
         </p:nvSpPr>
         <p:spPr>
           <a:xfrm>
-            <a:off x="566928" y="4023360"/>
-            <a:ext cx="365760" cy="365760"/>
+            <a:off x="566928" y="3712464"/>
+            <a:ext cx="347472" cy="347472"/>
           </a:xfrm>
           <a:prstGeom prst="ellipse">
             <a:avLst/>
@@ -12104,8 +12906,8 @@
         </p:nvSpPr>
         <p:spPr>
           <a:xfrm>
-            <a:off x="566928" y="4023360"/>
-            <a:ext cx="365760" cy="365760"/>
+            <a:off x="566928" y="3712464"/>
+            <a:ext cx="347472" cy="347472"/>
           </a:xfrm>
           <a:prstGeom prst="rect">
             <a:avLst/>
@@ -12121,7 +12923,7 @@
               <a:buNone/>
             </a:pPr>
             <a:r>
-              <a:rPr lang="en-US" sz="1300" b="1" dirty="0">
+              <a:rPr lang="en-US" sz="1250" b="1" dirty="0">
                 <a:solidFill>
                   <a:srgbClr val="FFFFFF"/>
                 </a:solidFill>
@@ -12131,7 +12933,7 @@
               </a:rPr>
               <a:t>5</a:t>
             </a:r>
-            <a:endParaRPr lang="en-US" sz="1300" dirty="0"/>
+            <a:endParaRPr lang="en-US" sz="1250" dirty="0"/>
           </a:p>
         </p:txBody>
       </p:sp>
@@ -12143,24 +12945,24 @@
         </p:nvSpPr>
         <p:spPr>
           <a:xfrm>
-            <a:off x="1133856" y="3968496"/>
-            <a:ext cx="8778240" cy="475488"/>
-          </a:xfrm>
-          <a:prstGeom prst="rect">
-            <a:avLst/>
-          </a:prstGeom>
-          <a:noFill/>
-          <a:ln/>
-        </p:spPr>
-        <p:txBody>
-          <a:bodyPr wrap="square" lIns="0" tIns="0" rIns="0" bIns="0" rtlCol="0" anchor="ctr"/>
-          <a:lstStyle/>
-          <a:p>
-            <a:pPr indent="0" marL="0">
-              <a:buNone/>
-            </a:pPr>
-            <a:r>
-              <a:rPr lang="en-US" sz="1400" dirty="0">
+            <a:off x="1115568" y="3675888"/>
+            <a:ext cx="8869680" cy="438912"/>
+          </a:xfrm>
+          <a:prstGeom prst="rect">
+            <a:avLst/>
+          </a:prstGeom>
+          <a:noFill/>
+          <a:ln/>
+        </p:spPr>
+        <p:txBody>
+          <a:bodyPr wrap="square" lIns="0" tIns="0" rIns="0" bIns="0" rtlCol="0" anchor="ctr"/>
+          <a:lstStyle/>
+          <a:p>
+            <a:pPr indent="0" marL="0">
+              <a:buNone/>
+            </a:pPr>
+            <a:r>
+              <a:rPr lang="en-US" sz="1350" dirty="0">
                 <a:solidFill>
                   <a:srgbClr val="FFFFFF"/>
                 </a:solidFill>
@@ -12170,20 +12972,118 @@
               </a:rPr>
               <a:t>Ab dem 01.10. sind wir auch in Dortmund.</a:t>
             </a:r>
-            <a:endParaRPr lang="en-US" sz="1400" dirty="0"/>
-          </a:p>
-        </p:txBody>
-      </p:sp>
-      <p:sp>
-        <p:nvSpPr>
-          <p:cNvPr id="20" name="Text 18"/>
-          <p:cNvSpPr/>
-          <p:nvPr/>
-        </p:nvSpPr>
-        <p:spPr>
-          <a:xfrm>
-            <a:off x="566928" y="4892040"/>
-            <a:ext cx="7315200" cy="502920"/>
+            <a:endParaRPr lang="en-US" sz="1350" dirty="0"/>
+          </a:p>
+        </p:txBody>
+      </p:sp>
+      <p:sp>
+        <p:nvSpPr>
+          <p:cNvPr id="20" name="Shape 18"/>
+          <p:cNvSpPr/>
+          <p:nvPr/>
+        </p:nvSpPr>
+        <p:spPr>
+          <a:xfrm>
+            <a:off x="566928" y="4261104"/>
+            <a:ext cx="347472" cy="347472"/>
+          </a:xfrm>
+          <a:prstGeom prst="ellipse">
+            <a:avLst/>
+          </a:prstGeom>
+          <a:solidFill>
+            <a:srgbClr val="2E7D3A"/>
+          </a:solidFill>
+          <a:ln/>
+        </p:spPr>
+      </p:sp>
+      <p:sp>
+        <p:nvSpPr>
+          <p:cNvPr id="21" name="Text 19"/>
+          <p:cNvSpPr/>
+          <p:nvPr/>
+        </p:nvSpPr>
+        <p:spPr>
+          <a:xfrm>
+            <a:off x="566928" y="4261104"/>
+            <a:ext cx="347472" cy="347472"/>
+          </a:xfrm>
+          <a:prstGeom prst="rect">
+            <a:avLst/>
+          </a:prstGeom>
+          <a:noFill/>
+          <a:ln/>
+        </p:spPr>
+        <p:txBody>
+          <a:bodyPr wrap="square" lIns="0" tIns="0" rIns="0" bIns="0" rtlCol="0" anchor="ctr"/>
+          <a:lstStyle/>
+          <a:p>
+            <a:pPr algn="ctr" indent="0" marL="0">
+              <a:buNone/>
+            </a:pPr>
+            <a:r>
+              <a:rPr lang="en-US" sz="1250" b="1" dirty="0">
+                <a:solidFill>
+                  <a:srgbClr val="FFFFFF"/>
+                </a:solidFill>
+                <a:latin typeface="Calibri" pitchFamily="34" charset="0"/>
+                <a:ea typeface="Calibri" pitchFamily="34" charset="-122"/>
+                <a:cs typeface="Calibri" pitchFamily="34" charset="-120"/>
+              </a:rPr>
+              <a:t>6</a:t>
+            </a:r>
+            <a:endParaRPr lang="en-US" sz="1250" dirty="0"/>
+          </a:p>
+        </p:txBody>
+      </p:sp>
+      <p:sp>
+        <p:nvSpPr>
+          <p:cNvPr id="22" name="Text 20"/>
+          <p:cNvSpPr/>
+          <p:nvPr/>
+        </p:nvSpPr>
+        <p:spPr>
+          <a:xfrm>
+            <a:off x="1115568" y="4224528"/>
+            <a:ext cx="8869680" cy="438912"/>
+          </a:xfrm>
+          <a:prstGeom prst="rect">
+            <a:avLst/>
+          </a:prstGeom>
+          <a:noFill/>
+          <a:ln/>
+        </p:spPr>
+        <p:txBody>
+          <a:bodyPr wrap="square" lIns="0" tIns="0" rIns="0" bIns="0" rtlCol="0" anchor="ctr"/>
+          <a:lstStyle/>
+          <a:p>
+            <a:pPr indent="0" marL="0">
+              <a:buNone/>
+            </a:pPr>
+            <a:r>
+              <a:rPr lang="en-US" sz="1350" dirty="0">
+                <a:solidFill>
+                  <a:srgbClr val="FFFFFF"/>
+                </a:solidFill>
+                <a:latin typeface="Calibri" pitchFamily="34" charset="0"/>
+                <a:ea typeface="Calibri" pitchFamily="34" charset="-122"/>
+                <a:cs typeface="Calibri" pitchFamily="34" charset="-120"/>
+              </a:rPr>
+              <a:t>Wir suchen einen Handwerker oder Hausmeister - denkt bitte nach, wen ihr kennt.</a:t>
+            </a:r>
+            <a:endParaRPr lang="en-US" sz="1350" dirty="0"/>
+          </a:p>
+        </p:txBody>
+      </p:sp>
+      <p:sp>
+        <p:nvSpPr>
+          <p:cNvPr id="23" name="Text 21"/>
+          <p:cNvSpPr/>
+          <p:nvPr/>
+        </p:nvSpPr>
+        <p:spPr>
+          <a:xfrm>
+            <a:off x="566928" y="4956048"/>
+            <a:ext cx="7315200" cy="475488"/>
           </a:xfrm>
           <a:prstGeom prst="rect">
             <a:avLst/>
@@ -12215,14 +13115,14 @@
       </p:sp>
       <p:sp>
         <p:nvSpPr>
-          <p:cNvPr id="21" name="Text 19"/>
-          <p:cNvSpPr/>
-          <p:nvPr/>
-        </p:nvSpPr>
-        <p:spPr>
-          <a:xfrm>
-            <a:off x="566928" y="5394960"/>
-            <a:ext cx="8778240" cy="457200"/>
+          <p:cNvPr id="24" name="Text 22"/>
+          <p:cNvSpPr/>
+          <p:nvPr/>
+        </p:nvSpPr>
+        <p:spPr>
+          <a:xfrm>
+            <a:off x="566928" y="5468112"/>
+            <a:ext cx="8869680" cy="457200"/>
           </a:xfrm>
           <a:prstGeom prst="rect">
             <a:avLst/>
@@ -12257,7 +13157,7 @@
       </p:sp>
       <p:sp>
         <p:nvSpPr>
-          <p:cNvPr id="22" name="Text 20"/>
+          <p:cNvPr id="25" name="Text 23"/>
           <p:cNvSpPr/>
           <p:nvPr/>
         </p:nvSpPr>

</xml_diff>